<commit_message>
docs: update game guide slides
</commit_message>
<xml_diff>
--- a/docs/iisen-show-guide.pptx
+++ b/docs/iisen-show-guide.pptx
@@ -1329,7 +1329,7 @@
         <p:spPr>
           <a:xfrm>
             <a:off x="0" y="0"/>
-            <a:ext cx="164592" cy="5143500"/>
+            <a:ext cx="9144000" cy="256032"/>
           </a:xfrm>
           <a:prstGeom prst="rect">
             <a:avLst/>
@@ -1353,22 +1353,18 @@
         </p:nvSpPr>
         <p:spPr>
           <a:xfrm>
-            <a:off x="6858000" y="3657600"/>
-            <a:ext cx="2286000" cy="1485900"/>
-          </a:xfrm>
-          <a:prstGeom prst="rect">
-            <a:avLst/>
-          </a:prstGeom>
-          <a:solidFill>
-            <a:srgbClr val="2E7D8C">
-              <a:alpha val="50000"/>
-            </a:srgbClr>
+            <a:off x="502920" y="1554480"/>
+            <a:ext cx="128016" cy="1280160"/>
+          </a:xfrm>
+          <a:prstGeom prst="rect">
+            <a:avLst/>
+          </a:prstGeom>
+          <a:solidFill>
+            <a:srgbClr val="2E7D8C"/>
           </a:solidFill>
           <a:ln w="12700">
             <a:solidFill>
-              <a:srgbClr val="2E7D8C">
-                <a:alpha val="50000"/>
-              </a:srgbClr>
+              <a:srgbClr val="2E7D8C"/>
             </a:solidFill>
             <a:prstDash val="solid"/>
           </a:ln>
@@ -1382,8 +1378,8 @@
         </p:nvSpPr>
         <p:spPr>
           <a:xfrm>
-            <a:off x="457200" y="1188720"/>
-            <a:ext cx="8229600" cy="1463040"/>
+            <a:off x="749808" y="1463040"/>
+            <a:ext cx="8046720" cy="914400"/>
           </a:xfrm>
           <a:prstGeom prst="rect">
             <a:avLst/>
@@ -1392,24 +1388,24 @@
           <a:ln/>
         </p:spPr>
         <p:txBody>
-          <a:bodyPr wrap="square" rtlCol="0" anchor="ctr"/>
-          <a:lstStyle/>
-          <a:p>
-            <a:pPr algn="ctr" indent="0" marL="0">
-              <a:buNone/>
-            </a:pPr>
-            <a:r>
-              <a:rPr lang="en-US" sz="5200" b="1" dirty="0">
+          <a:bodyPr wrap="square" lIns="0" tIns="0" rIns="0" bIns="0" rtlCol="0" anchor="ctr"/>
+          <a:lstStyle/>
+          <a:p>
+            <a:pPr algn="l" indent="0" marL="0">
+              <a:buNone/>
+            </a:pPr>
+            <a:r>
+              <a:rPr lang="en-US" sz="4200" b="1" dirty="0">
                 <a:solidFill>
                   <a:srgbClr val="FFFFFF"/>
                 </a:solidFill>
-                <a:latin typeface="Noto Sans JP" pitchFamily="34" charset="0"/>
-                <a:ea typeface="Noto Sans JP" pitchFamily="34" charset="-122"/>
-                <a:cs typeface="Noto Sans JP" pitchFamily="34" charset="-120"/>
+                <a:latin typeface="Arial Black" pitchFamily="34" charset="0"/>
+                <a:ea typeface="Arial Black" pitchFamily="34" charset="-122"/>
+                <a:cs typeface="Arial Black" pitchFamily="34" charset="-120"/>
               </a:rPr>
               <a:t>いいセンいきまSHOW!</a:t>
             </a:r>
-            <a:endParaRPr lang="en-US" sz="5200" dirty="0"/>
+            <a:endParaRPr lang="en-US" sz="4200" dirty="0"/>
           </a:p>
         </p:txBody>
       </p:sp>
@@ -1421,8 +1417,8 @@
         </p:nvSpPr>
         <p:spPr>
           <a:xfrm>
-            <a:off x="457200" y="2743200"/>
-            <a:ext cx="8229600" cy="822960"/>
+            <a:off x="749808" y="2487168"/>
+            <a:ext cx="8046720" cy="548640"/>
           </a:xfrm>
           <a:prstGeom prst="rect">
             <a:avLst/>
@@ -1431,26 +1427,51 @@
           <a:ln/>
         </p:spPr>
         <p:txBody>
-          <a:bodyPr wrap="square" rtlCol="0" anchor="ctr"/>
-          <a:lstStyle/>
-          <a:p>
-            <a:pPr algn="ctr" indent="0" marL="0">
-              <a:buNone/>
-            </a:pPr>
-            <a:r>
-              <a:rPr lang="en-US" sz="2600" dirty="0">
-                <a:solidFill>
-                  <a:srgbClr val="2E7D8C"/>
-                </a:solidFill>
-                <a:latin typeface="Noto Sans JP" pitchFamily="34" charset="0"/>
-                <a:ea typeface="Noto Sans JP" pitchFamily="34" charset="-122"/>
-                <a:cs typeface="Noto Sans JP" pitchFamily="34" charset="-120"/>
+          <a:bodyPr wrap="square" lIns="0" tIns="0" rIns="0" bIns="0" rtlCol="0" anchor="ctr"/>
+          <a:lstStyle/>
+          <a:p>
+            <a:pPr algn="l" indent="0" marL="0">
+              <a:buNone/>
+            </a:pPr>
+            <a:r>
+              <a:rPr lang="en-US" sz="2000" dirty="0">
+                <a:solidFill>
+                  <a:srgbClr val="D8F0FC"/>
+                </a:solidFill>
+                <a:latin typeface="Calibri" pitchFamily="34" charset="0"/>
+                <a:ea typeface="Calibri" pitchFamily="34" charset="-122"/>
+                <a:cs typeface="Calibri" pitchFamily="34" charset="-120"/>
               </a:rPr>
               <a:t>数字でいいセンをねらえ！</a:t>
             </a:r>
-            <a:endParaRPr lang="en-US" sz="2600" dirty="0"/>
-          </a:p>
-        </p:txBody>
+            <a:endParaRPr lang="en-US" sz="2000" dirty="0"/>
+          </a:p>
+        </p:txBody>
+      </p:sp>
+      <p:sp>
+        <p:nvSpPr>
+          <p:cNvPr id="6" name="Shape 4"/>
+          <p:cNvSpPr/>
+          <p:nvPr/>
+        </p:nvSpPr>
+        <p:spPr>
+          <a:xfrm>
+            <a:off x="0" y="4754880"/>
+            <a:ext cx="9144000" cy="388620"/>
+          </a:xfrm>
+          <a:prstGeom prst="rect">
+            <a:avLst/>
+          </a:prstGeom>
+          <a:solidFill>
+            <a:srgbClr val="2E7D8C"/>
+          </a:solidFill>
+          <a:ln w="12700">
+            <a:solidFill>
+              <a:srgbClr val="2E7D8C"/>
+            </a:solidFill>
+            <a:prstDash val="solid"/>
+          </a:ln>
+        </p:spPr>
       </p:sp>
     </p:spTree>
   </p:cSld>
@@ -1493,7 +1514,7 @@
         <p:spPr>
           <a:xfrm>
             <a:off x="0" y="0"/>
-            <a:ext cx="9144000" cy="1005840"/>
+            <a:ext cx="9144000" cy="868680"/>
           </a:xfrm>
           <a:prstGeom prst="rect">
             <a:avLst/>
@@ -1511,55 +1532,16 @@
       </p:sp>
       <p:sp>
         <p:nvSpPr>
-          <p:cNvPr id="3" name="Text 1"/>
-          <p:cNvSpPr/>
-          <p:nvPr/>
-        </p:nvSpPr>
-        <p:spPr>
-          <a:xfrm>
-            <a:off x="365760" y="0"/>
-            <a:ext cx="8412480" cy="1005840"/>
-          </a:xfrm>
-          <a:prstGeom prst="rect">
-            <a:avLst/>
-          </a:prstGeom>
-          <a:noFill/>
-          <a:ln/>
-        </p:spPr>
-        <p:txBody>
-          <a:bodyPr wrap="square" lIns="0" tIns="0" rIns="0" bIns="0" rtlCol="0" anchor="ctr"/>
-          <a:lstStyle/>
-          <a:p>
-            <a:pPr algn="l" indent="0" marL="0">
-              <a:buNone/>
-            </a:pPr>
-            <a:r>
-              <a:rPr lang="en-US" sz="3200" b="1" dirty="0">
-                <a:solidFill>
-                  <a:srgbClr val="FFFFFF"/>
-                </a:solidFill>
-                <a:latin typeface="Noto Sans JP" pitchFamily="34" charset="0"/>
-                <a:ea typeface="Noto Sans JP" pitchFamily="34" charset="-122"/>
-                <a:cs typeface="Noto Sans JP" pitchFamily="34" charset="-120"/>
-              </a:rPr>
-              <a:t>どんなゲーム？</a:t>
-            </a:r>
-            <a:endParaRPr lang="en-US" sz="3200" dirty="0"/>
-          </a:p>
-        </p:txBody>
-      </p:sp>
-      <p:sp>
-        <p:nvSpPr>
-          <p:cNvPr id="4" name="Shape 2"/>
-          <p:cNvSpPr/>
-          <p:nvPr/>
-        </p:nvSpPr>
-        <p:spPr>
-          <a:xfrm>
-            <a:off x="457200" y="1417320"/>
-            <a:ext cx="457200" cy="457200"/>
-          </a:xfrm>
-          <a:prstGeom prst="ellipse">
+          <p:cNvPr id="3" name="Shape 1"/>
+          <p:cNvSpPr/>
+          <p:nvPr/>
+        </p:nvSpPr>
+        <p:spPr>
+          <a:xfrm>
+            <a:off x="0" y="0"/>
+            <a:ext cx="146304" cy="868680"/>
+          </a:xfrm>
+          <a:prstGeom prst="rect">
             <a:avLst/>
           </a:prstGeom>
           <a:solidFill>
@@ -1575,14 +1557,14 @@
       </p:sp>
       <p:sp>
         <p:nvSpPr>
-          <p:cNvPr id="5" name="Text 3"/>
-          <p:cNvSpPr/>
-          <p:nvPr/>
-        </p:nvSpPr>
-        <p:spPr>
-          <a:xfrm>
-            <a:off x="1097280" y="1371600"/>
-            <a:ext cx="7589520" cy="594360"/>
+          <p:cNvPr id="4" name="Text 2"/>
+          <p:cNvSpPr/>
+          <p:nvPr/>
+        </p:nvSpPr>
+        <p:spPr>
+          <a:xfrm>
+            <a:off x="274320" y="0"/>
+            <a:ext cx="8686800" cy="868680"/>
           </a:xfrm>
           <a:prstGeom prst="rect">
             <a:avLst/>
@@ -1591,26 +1573,58 @@
           <a:ln/>
         </p:spPr>
         <p:txBody>
-          <a:bodyPr wrap="square" rtlCol="0" anchor="ctr"/>
+          <a:bodyPr wrap="square" lIns="0" tIns="0" rIns="0" bIns="0" rtlCol="0" anchor="ctr"/>
           <a:lstStyle/>
           <a:p>
             <a:pPr algn="l" indent="0" marL="0">
               <a:buNone/>
             </a:pPr>
             <a:r>
-              <a:rPr lang="en-US" sz="2200" dirty="0">
-                <a:solidFill>
-                  <a:srgbClr val="1A1A1A"/>
-                </a:solidFill>
-                <a:latin typeface="Noto Sans JP" pitchFamily="34" charset="0"/>
-                <a:ea typeface="Noto Sans JP" pitchFamily="34" charset="-122"/>
-                <a:cs typeface="Noto Sans JP" pitchFamily="34" charset="-120"/>
-              </a:rPr>
-              <a:t>みんなで数字を答える</a:t>
-            </a:r>
-            <a:endParaRPr lang="en-US" sz="2200" dirty="0"/>
-          </a:p>
-        </p:txBody>
+              <a:rPr lang="en-US" sz="2600" b="1" dirty="0">
+                <a:solidFill>
+                  <a:srgbClr val="FFFFFF"/>
+                </a:solidFill>
+                <a:latin typeface="Arial Black" pitchFamily="34" charset="0"/>
+                <a:ea typeface="Arial Black" pitchFamily="34" charset="-122"/>
+                <a:cs typeface="Arial Black" pitchFamily="34" charset="-120"/>
+              </a:rPr>
+              <a:t>どんなゲーム？</a:t>
+            </a:r>
+            <a:endParaRPr lang="en-US" sz="2600" dirty="0"/>
+          </a:p>
+        </p:txBody>
+      </p:sp>
+      <p:sp>
+        <p:nvSpPr>
+          <p:cNvPr id="5" name="Shape 3"/>
+          <p:cNvSpPr/>
+          <p:nvPr/>
+        </p:nvSpPr>
+        <p:spPr>
+          <a:xfrm>
+            <a:off x="457200" y="1005840"/>
+            <a:ext cx="8229600" cy="914400"/>
+          </a:xfrm>
+          <a:prstGeom prst="rect">
+            <a:avLst/>
+          </a:prstGeom>
+          <a:solidFill>
+            <a:srgbClr val="F6F9FB"/>
+          </a:solidFill>
+          <a:ln w="12700">
+            <a:solidFill>
+              <a:srgbClr val="C8D8E0"/>
+            </a:solidFill>
+            <a:prstDash val="solid"/>
+          </a:ln>
+          <a:effectLst>
+            <a:outerShdw sx="100000" sy="100000" kx="0" ky="0" algn="bl" rotWithShape="0" blurRad="50800" dist="12700" dir="8100000">
+              <a:srgbClr val="000000">
+                <a:alpha val="8000"/>
+              </a:srgbClr>
+            </a:outerShdw>
+          </a:effectLst>
+        </p:spPr>
       </p:sp>
       <p:sp>
         <p:nvSpPr>
@@ -1620,10 +1634,10 @@
         </p:nvSpPr>
         <p:spPr>
           <a:xfrm>
-            <a:off x="457200" y="2514600"/>
-            <a:ext cx="457200" cy="457200"/>
-          </a:xfrm>
-          <a:prstGeom prst="ellipse">
+            <a:off x="457200" y="1005840"/>
+            <a:ext cx="91440" cy="914400"/>
+          </a:xfrm>
+          <a:prstGeom prst="rect">
             <a:avLst/>
           </a:prstGeom>
           <a:solidFill>
@@ -1645,8 +1659,8 @@
         </p:nvSpPr>
         <p:spPr>
           <a:xfrm>
-            <a:off x="1097280" y="2468880"/>
-            <a:ext cx="7589520" cy="594360"/>
+            <a:off x="713232" y="1005840"/>
+            <a:ext cx="7818120" cy="914400"/>
           </a:xfrm>
           <a:prstGeom prst="rect">
             <a:avLst/>
@@ -1655,24 +1669,24 @@
           <a:ln/>
         </p:spPr>
         <p:txBody>
-          <a:bodyPr wrap="square" rtlCol="0" anchor="ctr"/>
+          <a:bodyPr wrap="square" lIns="0" tIns="0" rIns="0" bIns="0" rtlCol="0" anchor="ctr"/>
           <a:lstStyle/>
           <a:p>
             <a:pPr algn="l" indent="0" marL="0">
               <a:buNone/>
             </a:pPr>
             <a:r>
-              <a:rPr lang="en-US" sz="2200" dirty="0">
-                <a:solidFill>
-                  <a:srgbClr val="1A1A1A"/>
-                </a:solidFill>
-                <a:latin typeface="Noto Sans JP" pitchFamily="34" charset="0"/>
-                <a:ea typeface="Noto Sans JP" pitchFamily="34" charset="-122"/>
-                <a:cs typeface="Noto Sans JP" pitchFamily="34" charset="-120"/>
-              </a:rPr>
-              <a:t>いちばん「真ん中の数字（中央値）」を答えた人が勝ち！</a:t>
-            </a:r>
-            <a:endParaRPr lang="en-US" sz="2200" dirty="0"/>
+              <a:rPr lang="en-US" sz="1900" dirty="0">
+                <a:solidFill>
+                  <a:srgbClr val="2A2A2A"/>
+                </a:solidFill>
+                <a:latin typeface="Calibri" pitchFamily="34" charset="0"/>
+                <a:ea typeface="Calibri" pitchFamily="34" charset="-122"/>
+                <a:cs typeface="Calibri" pitchFamily="34" charset="-120"/>
+              </a:rPr>
+              <a:t>みんなで数字を答える</a:t>
+            </a:r>
+            <a:endParaRPr lang="en-US" sz="1900" dirty="0"/>
           </a:p>
         </p:txBody>
       </p:sp>
@@ -1684,10 +1698,42 @@
         </p:nvSpPr>
         <p:spPr>
           <a:xfrm>
-            <a:off x="457200" y="3611880"/>
-            <a:ext cx="457200" cy="457200"/>
-          </a:xfrm>
-          <a:prstGeom prst="ellipse">
+            <a:off x="457200" y="2148840"/>
+            <a:ext cx="8229600" cy="914400"/>
+          </a:xfrm>
+          <a:prstGeom prst="rect">
+            <a:avLst/>
+          </a:prstGeom>
+          <a:solidFill>
+            <a:srgbClr val="E4F1F4"/>
+          </a:solidFill>
+          <a:ln w="25400">
+            <a:solidFill>
+              <a:srgbClr val="2E7D8C"/>
+            </a:solidFill>
+            <a:prstDash val="solid"/>
+          </a:ln>
+          <a:effectLst>
+            <a:outerShdw sx="100000" sy="100000" kx="0" ky="0" algn="bl" rotWithShape="0" blurRad="50800" dist="12700" dir="8100000">
+              <a:srgbClr val="000000">
+                <a:alpha val="8000"/>
+              </a:srgbClr>
+            </a:outerShdw>
+          </a:effectLst>
+        </p:spPr>
+      </p:sp>
+      <p:sp>
+        <p:nvSpPr>
+          <p:cNvPr id="9" name="Shape 7"/>
+          <p:cNvSpPr/>
+          <p:nvPr/>
+        </p:nvSpPr>
+        <p:spPr>
+          <a:xfrm>
+            <a:off x="457200" y="2148840"/>
+            <a:ext cx="91440" cy="914400"/>
+          </a:xfrm>
+          <a:prstGeom prst="rect">
             <a:avLst/>
           </a:prstGeom>
           <a:solidFill>
@@ -1703,14 +1749,14 @@
       </p:sp>
       <p:sp>
         <p:nvSpPr>
-          <p:cNvPr id="9" name="Text 7"/>
-          <p:cNvSpPr/>
-          <p:nvPr/>
-        </p:nvSpPr>
-        <p:spPr>
-          <a:xfrm>
-            <a:off x="1097280" y="3566160"/>
-            <a:ext cx="7589520" cy="594360"/>
+          <p:cNvPr id="10" name="Text 8"/>
+          <p:cNvSpPr/>
+          <p:nvPr/>
+        </p:nvSpPr>
+        <p:spPr>
+          <a:xfrm>
+            <a:off x="713232" y="2148840"/>
+            <a:ext cx="7818120" cy="914400"/>
           </a:xfrm>
           <a:prstGeom prst="rect">
             <a:avLst/>
@@ -1719,24 +1765,120 @@
           <a:ln/>
         </p:spPr>
         <p:txBody>
-          <a:bodyPr wrap="square" rtlCol="0" anchor="ctr"/>
+          <a:bodyPr wrap="square" lIns="0" tIns="0" rIns="0" bIns="0" rtlCol="0" anchor="ctr"/>
           <a:lstStyle/>
           <a:p>
             <a:pPr algn="l" indent="0" marL="0">
               <a:buNone/>
             </a:pPr>
             <a:r>
-              <a:rPr lang="en-US" sz="2200" dirty="0">
-                <a:solidFill>
-                  <a:srgbClr val="1A1A1A"/>
-                </a:solidFill>
-                <a:latin typeface="Noto Sans JP" pitchFamily="34" charset="0"/>
-                <a:ea typeface="Noto Sans JP" pitchFamily="34" charset="-122"/>
-                <a:cs typeface="Noto Sans JP" pitchFamily="34" charset="-120"/>
+              <a:rPr lang="en-US" sz="1900" dirty="0">
+                <a:solidFill>
+                  <a:srgbClr val="2A2A2A"/>
+                </a:solidFill>
+                <a:latin typeface="Calibri" pitchFamily="34" charset="0"/>
+                <a:ea typeface="Calibri" pitchFamily="34" charset="-122"/>
+                <a:cs typeface="Calibri" pitchFamily="34" charset="-120"/>
+              </a:rPr>
+              <a:t>いちばん「真ん中の数字（中央値）」を答えた人が勝ち！</a:t>
+            </a:r>
+            <a:endParaRPr lang="en-US" sz="1900" dirty="0"/>
+          </a:p>
+        </p:txBody>
+      </p:sp>
+      <p:sp>
+        <p:nvSpPr>
+          <p:cNvPr id="11" name="Shape 9"/>
+          <p:cNvSpPr/>
+          <p:nvPr/>
+        </p:nvSpPr>
+        <p:spPr>
+          <a:xfrm>
+            <a:off x="457200" y="3291840"/>
+            <a:ext cx="8229600" cy="914400"/>
+          </a:xfrm>
+          <a:prstGeom prst="rect">
+            <a:avLst/>
+          </a:prstGeom>
+          <a:solidFill>
+            <a:srgbClr val="F6F9FB"/>
+          </a:solidFill>
+          <a:ln w="12700">
+            <a:solidFill>
+              <a:srgbClr val="C8D8E0"/>
+            </a:solidFill>
+            <a:prstDash val="solid"/>
+          </a:ln>
+          <a:effectLst>
+            <a:outerShdw sx="100000" sy="100000" kx="0" ky="0" algn="bl" rotWithShape="0" blurRad="50800" dist="12700" dir="8100000">
+              <a:srgbClr val="000000">
+                <a:alpha val="8000"/>
+              </a:srgbClr>
+            </a:outerShdw>
+          </a:effectLst>
+        </p:spPr>
+      </p:sp>
+      <p:sp>
+        <p:nvSpPr>
+          <p:cNvPr id="12" name="Shape 10"/>
+          <p:cNvSpPr/>
+          <p:nvPr/>
+        </p:nvSpPr>
+        <p:spPr>
+          <a:xfrm>
+            <a:off x="457200" y="3291840"/>
+            <a:ext cx="91440" cy="914400"/>
+          </a:xfrm>
+          <a:prstGeom prst="rect">
+            <a:avLst/>
+          </a:prstGeom>
+          <a:solidFill>
+            <a:srgbClr val="2E7D8C"/>
+          </a:solidFill>
+          <a:ln w="12700">
+            <a:solidFill>
+              <a:srgbClr val="2E7D8C"/>
+            </a:solidFill>
+            <a:prstDash val="solid"/>
+          </a:ln>
+        </p:spPr>
+      </p:sp>
+      <p:sp>
+        <p:nvSpPr>
+          <p:cNvPr id="13" name="Text 11"/>
+          <p:cNvSpPr/>
+          <p:nvPr/>
+        </p:nvSpPr>
+        <p:spPr>
+          <a:xfrm>
+            <a:off x="713232" y="3291840"/>
+            <a:ext cx="7818120" cy="914400"/>
+          </a:xfrm>
+          <a:prstGeom prst="rect">
+            <a:avLst/>
+          </a:prstGeom>
+          <a:noFill/>
+          <a:ln/>
+        </p:spPr>
+        <p:txBody>
+          <a:bodyPr wrap="square" lIns="0" tIns="0" rIns="0" bIns="0" rtlCol="0" anchor="ctr"/>
+          <a:lstStyle/>
+          <a:p>
+            <a:pPr algn="l" indent="0" marL="0">
+              <a:buNone/>
+            </a:pPr>
+            <a:r>
+              <a:rPr lang="en-US" sz="1900" dirty="0">
+                <a:solidFill>
+                  <a:srgbClr val="2A2A2A"/>
+                </a:solidFill>
+                <a:latin typeface="Calibri" pitchFamily="34" charset="0"/>
+                <a:ea typeface="Calibri" pitchFamily="34" charset="-122"/>
+                <a:cs typeface="Calibri" pitchFamily="34" charset="-120"/>
               </a:rPr>
               <a:t>大きすぎても小さすぎてもダメ</a:t>
             </a:r>
-            <a:endParaRPr lang="en-US" sz="2200" dirty="0"/>
+            <a:endParaRPr lang="en-US" sz="1900" dirty="0"/>
           </a:p>
         </p:txBody>
       </p:sp>
@@ -1781,7 +1923,7 @@
         <p:spPr>
           <a:xfrm>
             <a:off x="0" y="0"/>
-            <a:ext cx="9144000" cy="1005840"/>
+            <a:ext cx="9144000" cy="868680"/>
           </a:xfrm>
           <a:prstGeom prst="rect">
             <a:avLst/>
@@ -1799,63 +1941,24 @@
       </p:sp>
       <p:sp>
         <p:nvSpPr>
-          <p:cNvPr id="3" name="Text 1"/>
-          <p:cNvSpPr/>
-          <p:nvPr/>
-        </p:nvSpPr>
-        <p:spPr>
-          <a:xfrm>
-            <a:off x="365760" y="0"/>
-            <a:ext cx="8412480" cy="1005840"/>
-          </a:xfrm>
-          <a:prstGeom prst="rect">
-            <a:avLst/>
-          </a:prstGeom>
-          <a:noFill/>
-          <a:ln/>
-        </p:spPr>
-        <p:txBody>
-          <a:bodyPr wrap="square" lIns="0" tIns="0" rIns="0" bIns="0" rtlCol="0" anchor="ctr"/>
-          <a:lstStyle/>
-          <a:p>
-            <a:pPr algn="l" indent="0" marL="0">
-              <a:buNone/>
-            </a:pPr>
-            <a:r>
-              <a:rPr lang="en-US" sz="3200" b="1" dirty="0">
-                <a:solidFill>
-                  <a:srgbClr val="FFFFFF"/>
-                </a:solidFill>
-                <a:latin typeface="Noto Sans JP" pitchFamily="34" charset="0"/>
-                <a:ea typeface="Noto Sans JP" pitchFamily="34" charset="-122"/>
-                <a:cs typeface="Noto Sans JP" pitchFamily="34" charset="-120"/>
-              </a:rPr>
-              <a:t>得点ルール</a:t>
-            </a:r>
-            <a:endParaRPr lang="en-US" sz="3200" dirty="0"/>
-          </a:p>
-        </p:txBody>
-      </p:sp>
-      <p:sp>
-        <p:nvSpPr>
-          <p:cNvPr id="4" name="Shape 2"/>
-          <p:cNvSpPr/>
-          <p:nvPr/>
-        </p:nvSpPr>
-        <p:spPr>
-          <a:xfrm>
-            <a:off x="365760" y="1234440"/>
-            <a:ext cx="8412480" cy="960120"/>
-          </a:xfrm>
-          <a:prstGeom prst="rect">
-            <a:avLst/>
-          </a:prstGeom>
-          <a:solidFill>
-            <a:srgbClr val="1F6E3C"/>
+          <p:cNvPr id="3" name="Shape 1"/>
+          <p:cNvSpPr/>
+          <p:nvPr/>
+        </p:nvSpPr>
+        <p:spPr>
+          <a:xfrm>
+            <a:off x="0" y="0"/>
+            <a:ext cx="146304" cy="868680"/>
+          </a:xfrm>
+          <a:prstGeom prst="rect">
+            <a:avLst/>
+          </a:prstGeom>
+          <a:solidFill>
+            <a:srgbClr val="2E7D8C"/>
           </a:solidFill>
           <a:ln w="12700">
             <a:solidFill>
-              <a:srgbClr val="1F6E3C"/>
+              <a:srgbClr val="2E7D8C"/>
             </a:solidFill>
             <a:prstDash val="solid"/>
           </a:ln>
@@ -1863,14 +1966,14 @@
       </p:sp>
       <p:sp>
         <p:nvSpPr>
-          <p:cNvPr id="5" name="Text 3"/>
-          <p:cNvSpPr/>
-          <p:nvPr/>
-        </p:nvSpPr>
-        <p:spPr>
-          <a:xfrm>
-            <a:off x="548640" y="1234440"/>
-            <a:ext cx="5943600" cy="960120"/>
+          <p:cNvPr id="4" name="Text 2"/>
+          <p:cNvSpPr/>
+          <p:nvPr/>
+        </p:nvSpPr>
+        <p:spPr>
+          <a:xfrm>
+            <a:off x="274320" y="0"/>
+            <a:ext cx="8686800" cy="868680"/>
           </a:xfrm>
           <a:prstGeom prst="rect">
             <a:avLst/>
@@ -1879,101 +1982,69 @@
           <a:ln/>
         </p:spPr>
         <p:txBody>
-          <a:bodyPr wrap="square" rtlCol="0" anchor="ctr"/>
+          <a:bodyPr wrap="square" lIns="0" tIns="0" rIns="0" bIns="0" rtlCol="0" anchor="ctr"/>
           <a:lstStyle/>
           <a:p>
             <a:pPr algn="l" indent="0" marL="0">
               <a:buNone/>
             </a:pPr>
             <a:r>
-              <a:rPr lang="en-US" sz="2000" b="1" dirty="0">
+              <a:rPr lang="en-US" sz="2600" b="1" dirty="0">
                 <a:solidFill>
                   <a:srgbClr val="FFFFFF"/>
                 </a:solidFill>
-                <a:latin typeface="Noto Sans JP" pitchFamily="34" charset="0"/>
-                <a:ea typeface="Noto Sans JP" pitchFamily="34" charset="-122"/>
-                <a:cs typeface="Noto Sans JP" pitchFamily="34" charset="-120"/>
-              </a:rPr>
-              <a:t>中央値を答えた人</a:t>
-            </a:r>
-            <a:endParaRPr lang="en-US" sz="2000" dirty="0"/>
-          </a:p>
-        </p:txBody>
-      </p:sp>
-      <p:sp>
-        <p:nvSpPr>
-          <p:cNvPr id="6" name="Text 4"/>
-          <p:cNvSpPr/>
-          <p:nvPr/>
-        </p:nvSpPr>
-        <p:spPr>
-          <a:xfrm>
-            <a:off x="6583680" y="1234440"/>
-            <a:ext cx="2011680" cy="960120"/>
-          </a:xfrm>
-          <a:prstGeom prst="rect">
-            <a:avLst/>
-          </a:prstGeom>
-          <a:noFill/>
-          <a:ln/>
-        </p:spPr>
-        <p:txBody>
-          <a:bodyPr wrap="square" rtlCol="0" anchor="ctr"/>
-          <a:lstStyle/>
-          <a:p>
-            <a:pPr algn="ctr" indent="0" marL="0">
-              <a:buNone/>
-            </a:pPr>
-            <a:r>
-              <a:rPr lang="en-US" sz="2800" b="1" dirty="0">
-                <a:solidFill>
-                  <a:srgbClr val="FFFFFF"/>
-                </a:solidFill>
-                <a:latin typeface="Noto Sans JP" pitchFamily="34" charset="0"/>
-                <a:ea typeface="Noto Sans JP" pitchFamily="34" charset="-122"/>
-                <a:cs typeface="Noto Sans JP" pitchFamily="34" charset="-120"/>
-              </a:rPr>
-              <a:t>＋50点</a:t>
-            </a:r>
-            <a:endParaRPr lang="en-US" sz="2800" dirty="0"/>
-          </a:p>
-        </p:txBody>
-      </p:sp>
-      <p:sp>
-        <p:nvSpPr>
-          <p:cNvPr id="7" name="Shape 5"/>
-          <p:cNvSpPr/>
-          <p:nvPr/>
-        </p:nvSpPr>
-        <p:spPr>
-          <a:xfrm>
-            <a:off x="365760" y="2423160"/>
-            <a:ext cx="8412480" cy="960120"/>
-          </a:xfrm>
-          <a:prstGeom prst="rect">
-            <a:avLst/>
-          </a:prstGeom>
-          <a:solidFill>
-            <a:srgbClr val="C0392B"/>
-          </a:solidFill>
-          <a:ln w="12700">
+                <a:latin typeface="Arial Black" pitchFamily="34" charset="0"/>
+                <a:ea typeface="Arial Black" pitchFamily="34" charset="-122"/>
+                <a:cs typeface="Arial Black" pitchFamily="34" charset="-120"/>
+              </a:rPr>
+              <a:t>得点ルール</a:t>
+            </a:r>
+            <a:endParaRPr lang="en-US" sz="2600" dirty="0"/>
+          </a:p>
+        </p:txBody>
+      </p:sp>
+      <p:sp>
+        <p:nvSpPr>
+          <p:cNvPr id="5" name="Shape 3"/>
+          <p:cNvSpPr/>
+          <p:nvPr/>
+        </p:nvSpPr>
+        <p:spPr>
+          <a:xfrm>
+            <a:off x="457200" y="1005840"/>
+            <a:ext cx="8229600" cy="1005840"/>
+          </a:xfrm>
+          <a:prstGeom prst="rect">
+            <a:avLst/>
+          </a:prstGeom>
+          <a:solidFill>
+            <a:srgbClr val="E2F5EC"/>
+          </a:solidFill>
+          <a:ln w="19050">
             <a:solidFill>
-              <a:srgbClr val="C0392B"/>
+              <a:srgbClr val="4CAF7D"/>
             </a:solidFill>
             <a:prstDash val="solid"/>
           </a:ln>
-        </p:spPr>
-      </p:sp>
-      <p:sp>
-        <p:nvSpPr>
-          <p:cNvPr id="8" name="Text 6"/>
-          <p:cNvSpPr/>
-          <p:nvPr/>
-        </p:nvSpPr>
-        <p:spPr>
-          <a:xfrm>
-            <a:off x="548640" y="2423160"/>
-            <a:ext cx="5943600" cy="960120"/>
+          <a:effectLst>
+            <a:outerShdw sx="100000" sy="100000" kx="0" ky="0" algn="bl" rotWithShape="0" blurRad="63500" dist="25400" dir="8100000">
+              <a:srgbClr val="000000">
+                <a:alpha val="9000"/>
+              </a:srgbClr>
+            </a:outerShdw>
+          </a:effectLst>
+        </p:spPr>
+      </p:sp>
+      <p:sp>
+        <p:nvSpPr>
+          <p:cNvPr id="6" name="Text 4"/>
+          <p:cNvSpPr/>
+          <p:nvPr/>
+        </p:nvSpPr>
+        <p:spPr>
+          <a:xfrm>
+            <a:off x="640080" y="1005840"/>
+            <a:ext cx="4754880" cy="1005840"/>
           </a:xfrm>
           <a:prstGeom prst="rect">
             <a:avLst/>
@@ -1982,37 +2053,37 @@
           <a:ln/>
         </p:spPr>
         <p:txBody>
-          <a:bodyPr wrap="square" rtlCol="0" anchor="ctr"/>
+          <a:bodyPr wrap="square" lIns="0" tIns="0" rIns="0" bIns="0" rtlCol="0" anchor="ctr"/>
           <a:lstStyle/>
           <a:p>
             <a:pPr algn="l" indent="0" marL="0">
               <a:buNone/>
             </a:pPr>
             <a:r>
-              <a:rPr lang="en-US" sz="2000" b="1" dirty="0">
-                <a:solidFill>
-                  <a:srgbClr val="FFFFFF"/>
-                </a:solidFill>
-                <a:latin typeface="Noto Sans JP" pitchFamily="34" charset="0"/>
-                <a:ea typeface="Noto Sans JP" pitchFamily="34" charset="-122"/>
-                <a:cs typeface="Noto Sans JP" pitchFamily="34" charset="-120"/>
-              </a:rPr>
-              <a:t>いちばん大きい・小さい数字を答えた人</a:t>
-            </a:r>
-            <a:endParaRPr lang="en-US" sz="2000" dirty="0"/>
-          </a:p>
-        </p:txBody>
-      </p:sp>
-      <p:sp>
-        <p:nvSpPr>
-          <p:cNvPr id="9" name="Text 7"/>
-          <p:cNvSpPr/>
-          <p:nvPr/>
-        </p:nvSpPr>
-        <p:spPr>
-          <a:xfrm>
-            <a:off x="6583680" y="2423160"/>
-            <a:ext cx="2011680" cy="960120"/>
+              <a:rPr lang="en-US" sz="1800" dirty="0">
+                <a:solidFill>
+                  <a:srgbClr val="2A2A2A"/>
+                </a:solidFill>
+                <a:latin typeface="Calibri" pitchFamily="34" charset="0"/>
+                <a:ea typeface="Calibri" pitchFamily="34" charset="-122"/>
+                <a:cs typeface="Calibri" pitchFamily="34" charset="-120"/>
+              </a:rPr>
+              <a:t>中央値を答えた人</a:t>
+            </a:r>
+            <a:endParaRPr lang="en-US" sz="1800" dirty="0"/>
+          </a:p>
+        </p:txBody>
+      </p:sp>
+      <p:sp>
+        <p:nvSpPr>
+          <p:cNvPr id="7" name="Text 5"/>
+          <p:cNvSpPr/>
+          <p:nvPr/>
+        </p:nvSpPr>
+        <p:spPr>
+          <a:xfrm>
+            <a:off x="5394960" y="1005840"/>
+            <a:ext cx="457200" cy="1005840"/>
           </a:xfrm>
           <a:prstGeom prst="rect">
             <a:avLst/>
@@ -2021,62 +2092,108 @@
           <a:ln/>
         </p:spPr>
         <p:txBody>
-          <a:bodyPr wrap="square" rtlCol="0" anchor="ctr"/>
+          <a:bodyPr wrap="square" lIns="0" tIns="0" rIns="0" bIns="0" rtlCol="0" anchor="ctr"/>
           <a:lstStyle/>
           <a:p>
             <a:pPr algn="ctr" indent="0" marL="0">
               <a:buNone/>
             </a:pPr>
             <a:r>
-              <a:rPr lang="en-US" sz="2800" b="1" dirty="0">
-                <a:solidFill>
-                  <a:srgbClr val="FFFFFF"/>
-                </a:solidFill>
-                <a:latin typeface="Noto Sans JP" pitchFamily="34" charset="0"/>
-                <a:ea typeface="Noto Sans JP" pitchFamily="34" charset="-122"/>
-                <a:cs typeface="Noto Sans JP" pitchFamily="34" charset="-120"/>
-              </a:rPr>
-              <a:t>－10点</a:t>
-            </a:r>
-            <a:endParaRPr lang="en-US" sz="2800" dirty="0"/>
-          </a:p>
-        </p:txBody>
-      </p:sp>
-      <p:sp>
-        <p:nvSpPr>
-          <p:cNvPr id="10" name="Shape 8"/>
-          <p:cNvSpPr/>
-          <p:nvPr/>
-        </p:nvSpPr>
-        <p:spPr>
-          <a:xfrm>
-            <a:off x="365760" y="3611880"/>
-            <a:ext cx="8412480" cy="960120"/>
-          </a:xfrm>
-          <a:prstGeom prst="rect">
-            <a:avLst/>
-          </a:prstGeom>
-          <a:solidFill>
-            <a:srgbClr val="6B7280"/>
-          </a:solidFill>
-          <a:ln w="12700">
+              <a:rPr lang="en-US" sz="2000" dirty="0">
+                <a:solidFill>
+                  <a:srgbClr val="888888"/>
+                </a:solidFill>
+                <a:latin typeface="Arial" pitchFamily="34" charset="0"/>
+                <a:ea typeface="Arial" pitchFamily="34" charset="-122"/>
+                <a:cs typeface="Arial" pitchFamily="34" charset="-120"/>
+              </a:rPr>
+              <a:t>→</a:t>
+            </a:r>
+            <a:endParaRPr lang="en-US" sz="2000" dirty="0"/>
+          </a:p>
+        </p:txBody>
+      </p:sp>
+      <p:sp>
+        <p:nvSpPr>
+          <p:cNvPr id="8" name="Text 6"/>
+          <p:cNvSpPr/>
+          <p:nvPr/>
+        </p:nvSpPr>
+        <p:spPr>
+          <a:xfrm>
+            <a:off x="5852160" y="1005840"/>
+            <a:ext cx="2468880" cy="1005840"/>
+          </a:xfrm>
+          <a:prstGeom prst="rect">
+            <a:avLst/>
+          </a:prstGeom>
+          <a:noFill/>
+          <a:ln/>
+        </p:spPr>
+        <p:txBody>
+          <a:bodyPr wrap="square" lIns="0" tIns="0" rIns="0" bIns="0" rtlCol="0" anchor="ctr"/>
+          <a:lstStyle/>
+          <a:p>
+            <a:pPr algn="ctr" indent="0" marL="0">
+              <a:buNone/>
+            </a:pPr>
+            <a:r>
+              <a:rPr lang="en-US" sz="3000" b="1" dirty="0">
+                <a:solidFill>
+                  <a:srgbClr val="1A6337"/>
+                </a:solidFill>
+                <a:latin typeface="Arial Black" pitchFamily="34" charset="0"/>
+                <a:ea typeface="Arial Black" pitchFamily="34" charset="-122"/>
+                <a:cs typeface="Arial Black" pitchFamily="34" charset="-120"/>
+              </a:rPr>
+              <a:t>＋50点</a:t>
+            </a:r>
+            <a:endParaRPr lang="en-US" sz="3000" dirty="0"/>
+          </a:p>
+        </p:txBody>
+      </p:sp>
+      <p:sp>
+        <p:nvSpPr>
+          <p:cNvPr id="9" name="Shape 7"/>
+          <p:cNvSpPr/>
+          <p:nvPr/>
+        </p:nvSpPr>
+        <p:spPr>
+          <a:xfrm>
+            <a:off x="457200" y="2194560"/>
+            <a:ext cx="8229600" cy="1005840"/>
+          </a:xfrm>
+          <a:prstGeom prst="rect">
+            <a:avLst/>
+          </a:prstGeom>
+          <a:solidFill>
+            <a:srgbClr val="FDE8E8"/>
+          </a:solidFill>
+          <a:ln w="19050">
             <a:solidFill>
-              <a:srgbClr val="6B7280"/>
+              <a:srgbClr val="E57373"/>
             </a:solidFill>
             <a:prstDash val="solid"/>
           </a:ln>
-        </p:spPr>
-      </p:sp>
-      <p:sp>
-        <p:nvSpPr>
-          <p:cNvPr id="11" name="Text 9"/>
-          <p:cNvSpPr/>
-          <p:nvPr/>
-        </p:nvSpPr>
-        <p:spPr>
-          <a:xfrm>
-            <a:off x="548640" y="3611880"/>
-            <a:ext cx="5943600" cy="960120"/>
+          <a:effectLst>
+            <a:outerShdw sx="100000" sy="100000" kx="0" ky="0" algn="bl" rotWithShape="0" blurRad="63500" dist="25400" dir="8100000">
+              <a:srgbClr val="000000">
+                <a:alpha val="9000"/>
+              </a:srgbClr>
+            </a:outerShdw>
+          </a:effectLst>
+        </p:spPr>
+      </p:sp>
+      <p:sp>
+        <p:nvSpPr>
+          <p:cNvPr id="10" name="Text 8"/>
+          <p:cNvSpPr/>
+          <p:nvPr/>
+        </p:nvSpPr>
+        <p:spPr>
+          <a:xfrm>
+            <a:off x="640080" y="2194560"/>
+            <a:ext cx="4754880" cy="1005840"/>
           </a:xfrm>
           <a:prstGeom prst="rect">
             <a:avLst/>
@@ -2085,37 +2202,37 @@
           <a:ln/>
         </p:spPr>
         <p:txBody>
-          <a:bodyPr wrap="square" rtlCol="0" anchor="ctr"/>
+          <a:bodyPr wrap="square" lIns="0" tIns="0" rIns="0" bIns="0" rtlCol="0" anchor="ctr"/>
           <a:lstStyle/>
           <a:p>
             <a:pPr algn="l" indent="0" marL="0">
               <a:buNone/>
             </a:pPr>
             <a:r>
-              <a:rPr lang="en-US" sz="2000" b="1" dirty="0">
-                <a:solidFill>
-                  <a:srgbClr val="FFFFFF"/>
-                </a:solidFill>
-                <a:latin typeface="Noto Sans JP" pitchFamily="34" charset="0"/>
-                <a:ea typeface="Noto Sans JP" pitchFamily="34" charset="-122"/>
-                <a:cs typeface="Noto Sans JP" pitchFamily="34" charset="-120"/>
-              </a:rPr>
-              <a:t>それ以外の人</a:t>
-            </a:r>
-            <a:endParaRPr lang="en-US" sz="2000" dirty="0"/>
-          </a:p>
-        </p:txBody>
-      </p:sp>
-      <p:sp>
-        <p:nvSpPr>
-          <p:cNvPr id="12" name="Text 10"/>
-          <p:cNvSpPr/>
-          <p:nvPr/>
-        </p:nvSpPr>
-        <p:spPr>
-          <a:xfrm>
-            <a:off x="6583680" y="3611880"/>
-            <a:ext cx="2011680" cy="960120"/>
+              <a:rPr lang="en-US" sz="1800" dirty="0">
+                <a:solidFill>
+                  <a:srgbClr val="2A2A2A"/>
+                </a:solidFill>
+                <a:latin typeface="Calibri" pitchFamily="34" charset="0"/>
+                <a:ea typeface="Calibri" pitchFamily="34" charset="-122"/>
+                <a:cs typeface="Calibri" pitchFamily="34" charset="-120"/>
+              </a:rPr>
+              <a:t>いちばん大きい・小さい数字を答えた人</a:t>
+            </a:r>
+            <a:endParaRPr lang="en-US" sz="1800" dirty="0"/>
+          </a:p>
+        </p:txBody>
+      </p:sp>
+      <p:sp>
+        <p:nvSpPr>
+          <p:cNvPr id="11" name="Text 9"/>
+          <p:cNvSpPr/>
+          <p:nvPr/>
+        </p:nvSpPr>
+        <p:spPr>
+          <a:xfrm>
+            <a:off x="5394960" y="2194560"/>
+            <a:ext cx="457200" cy="1005840"/>
           </a:xfrm>
           <a:prstGeom prst="rect">
             <a:avLst/>
@@ -2124,24 +2241,212 @@
           <a:ln/>
         </p:spPr>
         <p:txBody>
-          <a:bodyPr wrap="square" rtlCol="0" anchor="ctr"/>
+          <a:bodyPr wrap="square" lIns="0" tIns="0" rIns="0" bIns="0" rtlCol="0" anchor="ctr"/>
           <a:lstStyle/>
           <a:p>
             <a:pPr algn="ctr" indent="0" marL="0">
               <a:buNone/>
             </a:pPr>
             <a:r>
-              <a:rPr lang="en-US" sz="2800" b="1" dirty="0">
-                <a:solidFill>
-                  <a:srgbClr val="FFFFFF"/>
-                </a:solidFill>
-                <a:latin typeface="Noto Sans JP" pitchFamily="34" charset="0"/>
-                <a:ea typeface="Noto Sans JP" pitchFamily="34" charset="-122"/>
-                <a:cs typeface="Noto Sans JP" pitchFamily="34" charset="-120"/>
-              </a:rPr>
-              <a:t>0点</a:t>
-            </a:r>
-            <a:endParaRPr lang="en-US" sz="2800" dirty="0"/>
+              <a:rPr lang="en-US" sz="2000" dirty="0">
+                <a:solidFill>
+                  <a:srgbClr val="888888"/>
+                </a:solidFill>
+                <a:latin typeface="Arial" pitchFamily="34" charset="0"/>
+                <a:ea typeface="Arial" pitchFamily="34" charset="-122"/>
+                <a:cs typeface="Arial" pitchFamily="34" charset="-120"/>
+              </a:rPr>
+              <a:t>→</a:t>
+            </a:r>
+            <a:endParaRPr lang="en-US" sz="2000" dirty="0"/>
+          </a:p>
+        </p:txBody>
+      </p:sp>
+      <p:sp>
+        <p:nvSpPr>
+          <p:cNvPr id="12" name="Text 10"/>
+          <p:cNvSpPr/>
+          <p:nvPr/>
+        </p:nvSpPr>
+        <p:spPr>
+          <a:xfrm>
+            <a:off x="5852160" y="2194560"/>
+            <a:ext cx="2468880" cy="1005840"/>
+          </a:xfrm>
+          <a:prstGeom prst="rect">
+            <a:avLst/>
+          </a:prstGeom>
+          <a:noFill/>
+          <a:ln/>
+        </p:spPr>
+        <p:txBody>
+          <a:bodyPr wrap="square" lIns="0" tIns="0" rIns="0" bIns="0" rtlCol="0" anchor="ctr"/>
+          <a:lstStyle/>
+          <a:p>
+            <a:pPr algn="ctr" indent="0" marL="0">
+              <a:buNone/>
+            </a:pPr>
+            <a:r>
+              <a:rPr lang="en-US" sz="3000" b="1" dirty="0">
+                <a:solidFill>
+                  <a:srgbClr val="B91C1C"/>
+                </a:solidFill>
+                <a:latin typeface="Arial Black" pitchFamily="34" charset="0"/>
+                <a:ea typeface="Arial Black" pitchFamily="34" charset="-122"/>
+                <a:cs typeface="Arial Black" pitchFamily="34" charset="-120"/>
+              </a:rPr>
+              <a:t>－10点</a:t>
+            </a:r>
+            <a:endParaRPr lang="en-US" sz="3000" dirty="0"/>
+          </a:p>
+        </p:txBody>
+      </p:sp>
+      <p:sp>
+        <p:nvSpPr>
+          <p:cNvPr id="13" name="Shape 11"/>
+          <p:cNvSpPr/>
+          <p:nvPr/>
+        </p:nvSpPr>
+        <p:spPr>
+          <a:xfrm>
+            <a:off x="457200" y="3383280"/>
+            <a:ext cx="8229600" cy="1005840"/>
+          </a:xfrm>
+          <a:prstGeom prst="rect">
+            <a:avLst/>
+          </a:prstGeom>
+          <a:solidFill>
+            <a:srgbClr val="EEEEEE"/>
+          </a:solidFill>
+          <a:ln w="19050">
+            <a:solidFill>
+              <a:srgbClr val="BBBBBB"/>
+            </a:solidFill>
+            <a:prstDash val="solid"/>
+          </a:ln>
+          <a:effectLst>
+            <a:outerShdw sx="100000" sy="100000" kx="0" ky="0" algn="bl" rotWithShape="0" blurRad="63500" dist="25400" dir="8100000">
+              <a:srgbClr val="000000">
+                <a:alpha val="9000"/>
+              </a:srgbClr>
+            </a:outerShdw>
+          </a:effectLst>
+        </p:spPr>
+      </p:sp>
+      <p:sp>
+        <p:nvSpPr>
+          <p:cNvPr id="14" name="Text 12"/>
+          <p:cNvSpPr/>
+          <p:nvPr/>
+        </p:nvSpPr>
+        <p:spPr>
+          <a:xfrm>
+            <a:off x="640080" y="3383280"/>
+            <a:ext cx="4754880" cy="1005840"/>
+          </a:xfrm>
+          <a:prstGeom prst="rect">
+            <a:avLst/>
+          </a:prstGeom>
+          <a:noFill/>
+          <a:ln/>
+        </p:spPr>
+        <p:txBody>
+          <a:bodyPr wrap="square" lIns="0" tIns="0" rIns="0" bIns="0" rtlCol="0" anchor="ctr"/>
+          <a:lstStyle/>
+          <a:p>
+            <a:pPr algn="l" indent="0" marL="0">
+              <a:buNone/>
+            </a:pPr>
+            <a:r>
+              <a:rPr lang="en-US" sz="1800" dirty="0">
+                <a:solidFill>
+                  <a:srgbClr val="2A2A2A"/>
+                </a:solidFill>
+                <a:latin typeface="Calibri" pitchFamily="34" charset="0"/>
+                <a:ea typeface="Calibri" pitchFamily="34" charset="-122"/>
+                <a:cs typeface="Calibri" pitchFamily="34" charset="-120"/>
+              </a:rPr>
+              <a:t>それ以外</a:t>
+            </a:r>
+            <a:endParaRPr lang="en-US" sz="1800" dirty="0"/>
+          </a:p>
+        </p:txBody>
+      </p:sp>
+      <p:sp>
+        <p:nvSpPr>
+          <p:cNvPr id="15" name="Text 13"/>
+          <p:cNvSpPr/>
+          <p:nvPr/>
+        </p:nvSpPr>
+        <p:spPr>
+          <a:xfrm>
+            <a:off x="5394960" y="3383280"/>
+            <a:ext cx="457200" cy="1005840"/>
+          </a:xfrm>
+          <a:prstGeom prst="rect">
+            <a:avLst/>
+          </a:prstGeom>
+          <a:noFill/>
+          <a:ln/>
+        </p:spPr>
+        <p:txBody>
+          <a:bodyPr wrap="square" lIns="0" tIns="0" rIns="0" bIns="0" rtlCol="0" anchor="ctr"/>
+          <a:lstStyle/>
+          <a:p>
+            <a:pPr algn="ctr" indent="0" marL="0">
+              <a:buNone/>
+            </a:pPr>
+            <a:r>
+              <a:rPr lang="en-US" sz="2000" dirty="0">
+                <a:solidFill>
+                  <a:srgbClr val="888888"/>
+                </a:solidFill>
+                <a:latin typeface="Arial" pitchFamily="34" charset="0"/>
+                <a:ea typeface="Arial" pitchFamily="34" charset="-122"/>
+                <a:cs typeface="Arial" pitchFamily="34" charset="-120"/>
+              </a:rPr>
+              <a:t>→</a:t>
+            </a:r>
+            <a:endParaRPr lang="en-US" sz="2000" dirty="0"/>
+          </a:p>
+        </p:txBody>
+      </p:sp>
+      <p:sp>
+        <p:nvSpPr>
+          <p:cNvPr id="16" name="Text 14"/>
+          <p:cNvSpPr/>
+          <p:nvPr/>
+        </p:nvSpPr>
+        <p:spPr>
+          <a:xfrm>
+            <a:off x="5852160" y="3383280"/>
+            <a:ext cx="2468880" cy="1005840"/>
+          </a:xfrm>
+          <a:prstGeom prst="rect">
+            <a:avLst/>
+          </a:prstGeom>
+          <a:noFill/>
+          <a:ln/>
+        </p:spPr>
+        <p:txBody>
+          <a:bodyPr wrap="square" lIns="0" tIns="0" rIns="0" bIns="0" rtlCol="0" anchor="ctr"/>
+          <a:lstStyle/>
+          <a:p>
+            <a:pPr algn="ctr" indent="0" marL="0">
+              <a:buNone/>
+            </a:pPr>
+            <a:r>
+              <a:rPr lang="en-US" sz="3000" b="1" dirty="0">
+                <a:solidFill>
+                  <a:srgbClr val="555555"/>
+                </a:solidFill>
+                <a:latin typeface="Arial Black" pitchFamily="34" charset="0"/>
+                <a:ea typeface="Arial Black" pitchFamily="34" charset="-122"/>
+                <a:cs typeface="Arial Black" pitchFamily="34" charset="-120"/>
+              </a:rPr>
+              <a:t>　0点</a:t>
+            </a:r>
+            <a:endParaRPr lang="en-US" sz="3000" dirty="0"/>
           </a:p>
         </p:txBody>
       </p:sp>
@@ -2186,7 +2491,7 @@
         <p:spPr>
           <a:xfrm>
             <a:off x="0" y="0"/>
-            <a:ext cx="9144000" cy="1005840"/>
+            <a:ext cx="9144000" cy="868680"/>
           </a:xfrm>
           <a:prstGeom prst="rect">
             <a:avLst/>
@@ -2204,55 +2509,16 @@
       </p:sp>
       <p:sp>
         <p:nvSpPr>
-          <p:cNvPr id="3" name="Text 1"/>
-          <p:cNvSpPr/>
-          <p:nvPr/>
-        </p:nvSpPr>
-        <p:spPr>
-          <a:xfrm>
-            <a:off x="365760" y="0"/>
-            <a:ext cx="8412480" cy="1005840"/>
-          </a:xfrm>
-          <a:prstGeom prst="rect">
-            <a:avLst/>
-          </a:prstGeom>
-          <a:noFill/>
-          <a:ln/>
-        </p:spPr>
-        <p:txBody>
-          <a:bodyPr wrap="square" lIns="0" tIns="0" rIns="0" bIns="0" rtlCol="0" anchor="ctr"/>
-          <a:lstStyle/>
-          <a:p>
-            <a:pPr algn="l" indent="0" marL="0">
-              <a:buNone/>
-            </a:pPr>
-            <a:r>
-              <a:rPr lang="en-US" sz="3200" b="1" dirty="0">
-                <a:solidFill>
-                  <a:srgbClr val="FFFFFF"/>
-                </a:solidFill>
-                <a:latin typeface="Noto Sans JP" pitchFamily="34" charset="0"/>
-                <a:ea typeface="Noto Sans JP" pitchFamily="34" charset="-122"/>
-                <a:cs typeface="Noto Sans JP" pitchFamily="34" charset="-120"/>
-              </a:rPr>
-              <a:t>遊び方</a:t>
-            </a:r>
-            <a:endParaRPr lang="en-US" sz="3200" dirty="0"/>
-          </a:p>
-        </p:txBody>
-      </p:sp>
-      <p:sp>
-        <p:nvSpPr>
-          <p:cNvPr id="4" name="Shape 2"/>
-          <p:cNvSpPr/>
-          <p:nvPr/>
-        </p:nvSpPr>
-        <p:spPr>
-          <a:xfrm>
-            <a:off x="365760" y="1280160"/>
-            <a:ext cx="548640" cy="548640"/>
-          </a:xfrm>
-          <a:prstGeom prst="ellipse">
+          <p:cNvPr id="3" name="Shape 1"/>
+          <p:cNvSpPr/>
+          <p:nvPr/>
+        </p:nvSpPr>
+        <p:spPr>
+          <a:xfrm>
+            <a:off x="0" y="0"/>
+            <a:ext cx="146304" cy="868680"/>
+          </a:xfrm>
+          <a:prstGeom prst="rect">
             <a:avLst/>
           </a:prstGeom>
           <a:solidFill>
@@ -2268,14 +2534,14 @@
       </p:sp>
       <p:sp>
         <p:nvSpPr>
-          <p:cNvPr id="5" name="Text 3"/>
-          <p:cNvSpPr/>
-          <p:nvPr/>
-        </p:nvSpPr>
-        <p:spPr>
-          <a:xfrm>
-            <a:off x="365760" y="1280160"/>
-            <a:ext cx="548640" cy="548640"/>
+          <p:cNvPr id="4" name="Text 2"/>
+          <p:cNvSpPr/>
+          <p:nvPr/>
+        </p:nvSpPr>
+        <p:spPr>
+          <a:xfrm>
+            <a:off x="274320" y="0"/>
+            <a:ext cx="8686800" cy="868680"/>
           </a:xfrm>
           <a:prstGeom prst="rect">
             <a:avLst/>
@@ -2287,73 +2553,34 @@
           <a:bodyPr wrap="square" lIns="0" tIns="0" rIns="0" bIns="0" rtlCol="0" anchor="ctr"/>
           <a:lstStyle/>
           <a:p>
-            <a:pPr algn="ctr" indent="0" marL="0">
-              <a:buNone/>
-            </a:pPr>
-            <a:r>
-              <a:rPr lang="en-US" sz="2000" b="1" dirty="0">
+            <a:pPr algn="l" indent="0" marL="0">
+              <a:buNone/>
+            </a:pPr>
+            <a:r>
+              <a:rPr lang="en-US" sz="2600" b="1" dirty="0">
                 <a:solidFill>
                   <a:srgbClr val="FFFFFF"/>
                 </a:solidFill>
-                <a:latin typeface="Noto Sans JP" pitchFamily="34" charset="0"/>
-                <a:ea typeface="Noto Sans JP" pitchFamily="34" charset="-122"/>
-                <a:cs typeface="Noto Sans JP" pitchFamily="34" charset="-120"/>
-              </a:rPr>
-              <a:t>1</a:t>
-            </a:r>
-            <a:endParaRPr lang="en-US" sz="2000" dirty="0"/>
-          </a:p>
-        </p:txBody>
-      </p:sp>
-      <p:sp>
-        <p:nvSpPr>
-          <p:cNvPr id="6" name="Text 4"/>
-          <p:cNvSpPr/>
-          <p:nvPr/>
-        </p:nvSpPr>
-        <p:spPr>
-          <a:xfrm>
-            <a:off x="1097280" y="1234440"/>
-            <a:ext cx="7589520" cy="658368"/>
-          </a:xfrm>
-          <a:prstGeom prst="rect">
-            <a:avLst/>
-          </a:prstGeom>
-          <a:noFill/>
-          <a:ln/>
-        </p:spPr>
-        <p:txBody>
-          <a:bodyPr wrap="square" rtlCol="0" anchor="ctr"/>
-          <a:lstStyle/>
-          <a:p>
-            <a:pPr algn="l" indent="0" marL="0">
-              <a:buNone/>
-            </a:pPr>
-            <a:r>
-              <a:rPr lang="en-US" sz="2200" dirty="0">
-                <a:solidFill>
-                  <a:srgbClr val="1A1A1A"/>
-                </a:solidFill>
-                <a:latin typeface="Noto Sans JP" pitchFamily="34" charset="0"/>
-                <a:ea typeface="Noto Sans JP" pitchFamily="34" charset="-122"/>
-                <a:cs typeface="Noto Sans JP" pitchFamily="34" charset="-120"/>
-              </a:rPr>
-              <a:t>ルームコードを入力して参加</a:t>
-            </a:r>
-            <a:endParaRPr lang="en-US" sz="2200" dirty="0"/>
-          </a:p>
-        </p:txBody>
-      </p:sp>
-      <p:sp>
-        <p:nvSpPr>
-          <p:cNvPr id="7" name="Shape 5"/>
-          <p:cNvSpPr/>
-          <p:nvPr/>
-        </p:nvSpPr>
-        <p:spPr>
-          <a:xfrm>
-            <a:off x="365760" y="2194560"/>
-            <a:ext cx="548640" cy="548640"/>
+                <a:latin typeface="Arial Black" pitchFamily="34" charset="0"/>
+                <a:ea typeface="Arial Black" pitchFamily="34" charset="-122"/>
+                <a:cs typeface="Arial Black" pitchFamily="34" charset="-120"/>
+              </a:rPr>
+              <a:t>遊び方</a:t>
+            </a:r>
+            <a:endParaRPr lang="en-US" sz="2600" dirty="0"/>
+          </a:p>
+        </p:txBody>
+      </p:sp>
+      <p:sp>
+        <p:nvSpPr>
+          <p:cNvPr id="5" name="Shape 3"/>
+          <p:cNvSpPr/>
+          <p:nvPr/>
+        </p:nvSpPr>
+        <p:spPr>
+          <a:xfrm>
+            <a:off x="502920" y="1170432"/>
+            <a:ext cx="365760" cy="365760"/>
           </a:xfrm>
           <a:prstGeom prst="ellipse">
             <a:avLst/>
@@ -2371,14 +2598,14 @@
       </p:sp>
       <p:sp>
         <p:nvSpPr>
-          <p:cNvPr id="8" name="Text 6"/>
-          <p:cNvSpPr/>
-          <p:nvPr/>
-        </p:nvSpPr>
-        <p:spPr>
-          <a:xfrm>
-            <a:off x="365760" y="2194560"/>
-            <a:ext cx="548640" cy="548640"/>
+          <p:cNvPr id="6" name="Text 4"/>
+          <p:cNvSpPr/>
+          <p:nvPr/>
+        </p:nvSpPr>
+        <p:spPr>
+          <a:xfrm>
+            <a:off x="502920" y="1170432"/>
+            <a:ext cx="365760" cy="365760"/>
           </a:xfrm>
           <a:prstGeom prst="rect">
             <a:avLst/>
@@ -2394,30 +2621,30 @@
               <a:buNone/>
             </a:pPr>
             <a:r>
-              <a:rPr lang="en-US" sz="2000" b="1" dirty="0">
+              <a:rPr lang="en-US" sz="1400" b="1" dirty="0">
                 <a:solidFill>
                   <a:srgbClr val="FFFFFF"/>
                 </a:solidFill>
-                <a:latin typeface="Noto Sans JP" pitchFamily="34" charset="0"/>
-                <a:ea typeface="Noto Sans JP" pitchFamily="34" charset="-122"/>
-                <a:cs typeface="Noto Sans JP" pitchFamily="34" charset="-120"/>
-              </a:rPr>
-              <a:t>2</a:t>
-            </a:r>
-            <a:endParaRPr lang="en-US" sz="2000" dirty="0"/>
-          </a:p>
-        </p:txBody>
-      </p:sp>
-      <p:sp>
-        <p:nvSpPr>
-          <p:cNvPr id="9" name="Text 7"/>
-          <p:cNvSpPr/>
-          <p:nvPr/>
-        </p:nvSpPr>
-        <p:spPr>
-          <a:xfrm>
-            <a:off x="1097280" y="2148840"/>
-            <a:ext cx="7589520" cy="658368"/>
+                <a:latin typeface="Arial Black" pitchFamily="34" charset="0"/>
+                <a:ea typeface="Arial Black" pitchFamily="34" charset="-122"/>
+                <a:cs typeface="Arial Black" pitchFamily="34" charset="-120"/>
+              </a:rPr>
+              <a:t>1</a:t>
+            </a:r>
+            <a:endParaRPr lang="en-US" sz="1400" dirty="0"/>
+          </a:p>
+        </p:txBody>
+      </p:sp>
+      <p:sp>
+        <p:nvSpPr>
+          <p:cNvPr id="7" name="Text 5"/>
+          <p:cNvSpPr/>
+          <p:nvPr/>
+        </p:nvSpPr>
+        <p:spPr>
+          <a:xfrm>
+            <a:off x="987552" y="1097280"/>
+            <a:ext cx="7680960" cy="512064"/>
           </a:xfrm>
           <a:prstGeom prst="rect">
             <a:avLst/>
@@ -2426,37 +2653,37 @@
           <a:ln/>
         </p:spPr>
         <p:txBody>
-          <a:bodyPr wrap="square" rtlCol="0" anchor="ctr"/>
+          <a:bodyPr wrap="square" lIns="0" tIns="0" rIns="0" bIns="0" rtlCol="0" anchor="ctr"/>
           <a:lstStyle/>
           <a:p>
             <a:pPr algn="l" indent="0" marL="0">
               <a:buNone/>
             </a:pPr>
             <a:r>
-              <a:rPr lang="en-US" sz="2200" dirty="0">
-                <a:solidFill>
-                  <a:srgbClr val="1A1A1A"/>
-                </a:solidFill>
-                <a:latin typeface="Noto Sans JP" pitchFamily="34" charset="0"/>
-                <a:ea typeface="Noto Sans JP" pitchFamily="34" charset="-122"/>
-                <a:cs typeface="Noto Sans JP" pitchFamily="34" charset="-120"/>
-              </a:rPr>
-              <a:t>問題が出たら数字で答える</a:t>
-            </a:r>
-            <a:endParaRPr lang="en-US" sz="2200" dirty="0"/>
-          </a:p>
-        </p:txBody>
-      </p:sp>
-      <p:sp>
-        <p:nvSpPr>
-          <p:cNvPr id="10" name="Shape 8"/>
-          <p:cNvSpPr/>
-          <p:nvPr/>
-        </p:nvSpPr>
-        <p:spPr>
-          <a:xfrm>
-            <a:off x="365760" y="3108960"/>
-            <a:ext cx="548640" cy="548640"/>
+              <a:rPr lang="en-US" sz="1700" dirty="0">
+                <a:solidFill>
+                  <a:srgbClr val="2A2A2A"/>
+                </a:solidFill>
+                <a:latin typeface="Calibri" pitchFamily="34" charset="0"/>
+                <a:ea typeface="Calibri" pitchFamily="34" charset="-122"/>
+                <a:cs typeface="Calibri" pitchFamily="34" charset="-120"/>
+              </a:rPr>
+              <a:t>ルームコードを入力して参加</a:t>
+            </a:r>
+            <a:endParaRPr lang="en-US" sz="1700" dirty="0"/>
+          </a:p>
+        </p:txBody>
+      </p:sp>
+      <p:sp>
+        <p:nvSpPr>
+          <p:cNvPr id="8" name="Shape 6"/>
+          <p:cNvSpPr/>
+          <p:nvPr/>
+        </p:nvSpPr>
+        <p:spPr>
+          <a:xfrm>
+            <a:off x="502920" y="2112264"/>
+            <a:ext cx="365760" cy="365760"/>
           </a:xfrm>
           <a:prstGeom prst="ellipse">
             <a:avLst/>
@@ -2474,14 +2701,14 @@
       </p:sp>
       <p:sp>
         <p:nvSpPr>
-          <p:cNvPr id="11" name="Text 9"/>
-          <p:cNvSpPr/>
-          <p:nvPr/>
-        </p:nvSpPr>
-        <p:spPr>
-          <a:xfrm>
-            <a:off x="365760" y="3108960"/>
-            <a:ext cx="548640" cy="548640"/>
+          <p:cNvPr id="9" name="Text 7"/>
+          <p:cNvSpPr/>
+          <p:nvPr/>
+        </p:nvSpPr>
+        <p:spPr>
+          <a:xfrm>
+            <a:off x="502920" y="2112264"/>
+            <a:ext cx="365760" cy="365760"/>
           </a:xfrm>
           <a:prstGeom prst="rect">
             <a:avLst/>
@@ -2497,30 +2724,30 @@
               <a:buNone/>
             </a:pPr>
             <a:r>
-              <a:rPr lang="en-US" sz="2000" b="1" dirty="0">
+              <a:rPr lang="en-US" sz="1400" b="1" dirty="0">
                 <a:solidFill>
                   <a:srgbClr val="FFFFFF"/>
                 </a:solidFill>
-                <a:latin typeface="Noto Sans JP" pitchFamily="34" charset="0"/>
-                <a:ea typeface="Noto Sans JP" pitchFamily="34" charset="-122"/>
-                <a:cs typeface="Noto Sans JP" pitchFamily="34" charset="-120"/>
-              </a:rPr>
-              <a:t>3</a:t>
-            </a:r>
-            <a:endParaRPr lang="en-US" sz="2000" dirty="0"/>
-          </a:p>
-        </p:txBody>
-      </p:sp>
-      <p:sp>
-        <p:nvSpPr>
-          <p:cNvPr id="12" name="Text 10"/>
-          <p:cNvSpPr/>
-          <p:nvPr/>
-        </p:nvSpPr>
-        <p:spPr>
-          <a:xfrm>
-            <a:off x="1097280" y="3063240"/>
-            <a:ext cx="7589520" cy="658368"/>
+                <a:latin typeface="Arial Black" pitchFamily="34" charset="0"/>
+                <a:ea typeface="Arial Black" pitchFamily="34" charset="-122"/>
+                <a:cs typeface="Arial Black" pitchFamily="34" charset="-120"/>
+              </a:rPr>
+              <a:t>2</a:t>
+            </a:r>
+            <a:endParaRPr lang="en-US" sz="1400" dirty="0"/>
+          </a:p>
+        </p:txBody>
+      </p:sp>
+      <p:sp>
+        <p:nvSpPr>
+          <p:cNvPr id="10" name="Text 8"/>
+          <p:cNvSpPr/>
+          <p:nvPr/>
+        </p:nvSpPr>
+        <p:spPr>
+          <a:xfrm>
+            <a:off x="987552" y="2039112"/>
+            <a:ext cx="7680960" cy="512064"/>
           </a:xfrm>
           <a:prstGeom prst="rect">
             <a:avLst/>
@@ -2529,37 +2756,37 @@
           <a:ln/>
         </p:spPr>
         <p:txBody>
-          <a:bodyPr wrap="square" rtlCol="0" anchor="ctr"/>
+          <a:bodyPr wrap="square" lIns="0" tIns="0" rIns="0" bIns="0" rtlCol="0" anchor="ctr"/>
           <a:lstStyle/>
           <a:p>
             <a:pPr algn="l" indent="0" marL="0">
               <a:buNone/>
             </a:pPr>
             <a:r>
-              <a:rPr lang="en-US" sz="2200" dirty="0">
-                <a:solidFill>
-                  <a:srgbClr val="1A1A1A"/>
-                </a:solidFill>
-                <a:latin typeface="Noto Sans JP" pitchFamily="34" charset="0"/>
-                <a:ea typeface="Noto Sans JP" pitchFamily="34" charset="-122"/>
-                <a:cs typeface="Noto Sans JP" pitchFamily="34" charset="-120"/>
-              </a:rPr>
-              <a:t>全員が答えたら結果発表！</a:t>
-            </a:r>
-            <a:endParaRPr lang="en-US" sz="2200" dirty="0"/>
-          </a:p>
-        </p:txBody>
-      </p:sp>
-      <p:sp>
-        <p:nvSpPr>
-          <p:cNvPr id="13" name="Shape 11"/>
-          <p:cNvSpPr/>
-          <p:nvPr/>
-        </p:nvSpPr>
-        <p:spPr>
-          <a:xfrm>
-            <a:off x="365760" y="4023360"/>
-            <a:ext cx="548640" cy="548640"/>
+              <a:rPr lang="en-US" sz="1700" dirty="0">
+                <a:solidFill>
+                  <a:srgbClr val="2A2A2A"/>
+                </a:solidFill>
+                <a:latin typeface="Calibri" pitchFamily="34" charset="0"/>
+                <a:ea typeface="Calibri" pitchFamily="34" charset="-122"/>
+                <a:cs typeface="Calibri" pitchFamily="34" charset="-120"/>
+              </a:rPr>
+              <a:t>問題が出たら数字で答える</a:t>
+            </a:r>
+            <a:endParaRPr lang="en-US" sz="1700" dirty="0"/>
+          </a:p>
+        </p:txBody>
+      </p:sp>
+      <p:sp>
+        <p:nvSpPr>
+          <p:cNvPr id="11" name="Shape 9"/>
+          <p:cNvSpPr/>
+          <p:nvPr/>
+        </p:nvSpPr>
+        <p:spPr>
+          <a:xfrm>
+            <a:off x="502920" y="3054096"/>
+            <a:ext cx="365760" cy="365760"/>
           </a:xfrm>
           <a:prstGeom prst="ellipse">
             <a:avLst/>
@@ -2577,14 +2804,14 @@
       </p:sp>
       <p:sp>
         <p:nvSpPr>
-          <p:cNvPr id="14" name="Text 12"/>
-          <p:cNvSpPr/>
-          <p:nvPr/>
-        </p:nvSpPr>
-        <p:spPr>
-          <a:xfrm>
-            <a:off x="365760" y="4023360"/>
-            <a:ext cx="548640" cy="548640"/>
+          <p:cNvPr id="12" name="Text 10"/>
+          <p:cNvSpPr/>
+          <p:nvPr/>
+        </p:nvSpPr>
+        <p:spPr>
+          <a:xfrm>
+            <a:off x="502920" y="3054096"/>
+            <a:ext cx="365760" cy="365760"/>
           </a:xfrm>
           <a:prstGeom prst="rect">
             <a:avLst/>
@@ -2600,30 +2827,30 @@
               <a:buNone/>
             </a:pPr>
             <a:r>
-              <a:rPr lang="en-US" sz="2000" b="1" dirty="0">
+              <a:rPr lang="en-US" sz="1400" b="1" dirty="0">
                 <a:solidFill>
                   <a:srgbClr val="FFFFFF"/>
                 </a:solidFill>
-                <a:latin typeface="Noto Sans JP" pitchFamily="34" charset="0"/>
-                <a:ea typeface="Noto Sans JP" pitchFamily="34" charset="-122"/>
-                <a:cs typeface="Noto Sans JP" pitchFamily="34" charset="-120"/>
-              </a:rPr>
-              <a:t>4</a:t>
-            </a:r>
-            <a:endParaRPr lang="en-US" sz="2000" dirty="0"/>
-          </a:p>
-        </p:txBody>
-      </p:sp>
-      <p:sp>
-        <p:nvSpPr>
-          <p:cNvPr id="15" name="Text 13"/>
-          <p:cNvSpPr/>
-          <p:nvPr/>
-        </p:nvSpPr>
-        <p:spPr>
-          <a:xfrm>
-            <a:off x="1097280" y="3977640"/>
-            <a:ext cx="7589520" cy="658368"/>
+                <a:latin typeface="Arial Black" pitchFamily="34" charset="0"/>
+                <a:ea typeface="Arial Black" pitchFamily="34" charset="-122"/>
+                <a:cs typeface="Arial Black" pitchFamily="34" charset="-120"/>
+              </a:rPr>
+              <a:t>3</a:t>
+            </a:r>
+            <a:endParaRPr lang="en-US" sz="1400" dirty="0"/>
+          </a:p>
+        </p:txBody>
+      </p:sp>
+      <p:sp>
+        <p:nvSpPr>
+          <p:cNvPr id="13" name="Text 11"/>
+          <p:cNvSpPr/>
+          <p:nvPr/>
+        </p:nvSpPr>
+        <p:spPr>
+          <a:xfrm>
+            <a:off x="987552" y="2980944"/>
+            <a:ext cx="7680960" cy="512064"/>
           </a:xfrm>
           <a:prstGeom prst="rect">
             <a:avLst/>
@@ -2632,24 +2859,127 @@
           <a:ln/>
         </p:spPr>
         <p:txBody>
-          <a:bodyPr wrap="square" rtlCol="0" anchor="ctr"/>
+          <a:bodyPr wrap="square" lIns="0" tIns="0" rIns="0" bIns="0" rtlCol="0" anchor="ctr"/>
           <a:lstStyle/>
           <a:p>
             <a:pPr algn="l" indent="0" marL="0">
               <a:buNone/>
             </a:pPr>
             <a:r>
-              <a:rPr lang="en-US" sz="2200" dirty="0">
-                <a:solidFill>
-                  <a:srgbClr val="1A1A1A"/>
-                </a:solidFill>
-                <a:latin typeface="Noto Sans JP" pitchFamily="34" charset="0"/>
-                <a:ea typeface="Noto Sans JP" pitchFamily="34" charset="-122"/>
-                <a:cs typeface="Noto Sans JP" pitchFamily="34" charset="-120"/>
+              <a:rPr lang="en-US" sz="1700" dirty="0">
+                <a:solidFill>
+                  <a:srgbClr val="2A2A2A"/>
+                </a:solidFill>
+                <a:latin typeface="Calibri" pitchFamily="34" charset="0"/>
+                <a:ea typeface="Calibri" pitchFamily="34" charset="-122"/>
+                <a:cs typeface="Calibri" pitchFamily="34" charset="-120"/>
+              </a:rPr>
+              <a:t>全員が答えたら結果発表！</a:t>
+            </a:r>
+            <a:endParaRPr lang="en-US" sz="1700" dirty="0"/>
+          </a:p>
+        </p:txBody>
+      </p:sp>
+      <p:sp>
+        <p:nvSpPr>
+          <p:cNvPr id="14" name="Shape 12"/>
+          <p:cNvSpPr/>
+          <p:nvPr/>
+        </p:nvSpPr>
+        <p:spPr>
+          <a:xfrm>
+            <a:off x="502920" y="3995928"/>
+            <a:ext cx="365760" cy="365760"/>
+          </a:xfrm>
+          <a:prstGeom prst="ellipse">
+            <a:avLst/>
+          </a:prstGeom>
+          <a:solidFill>
+            <a:srgbClr val="2E7D8C"/>
+          </a:solidFill>
+          <a:ln w="12700">
+            <a:solidFill>
+              <a:srgbClr val="2E7D8C"/>
+            </a:solidFill>
+            <a:prstDash val="solid"/>
+          </a:ln>
+        </p:spPr>
+      </p:sp>
+      <p:sp>
+        <p:nvSpPr>
+          <p:cNvPr id="15" name="Text 13"/>
+          <p:cNvSpPr/>
+          <p:nvPr/>
+        </p:nvSpPr>
+        <p:spPr>
+          <a:xfrm>
+            <a:off x="502920" y="3995928"/>
+            <a:ext cx="365760" cy="365760"/>
+          </a:xfrm>
+          <a:prstGeom prst="rect">
+            <a:avLst/>
+          </a:prstGeom>
+          <a:noFill/>
+          <a:ln/>
+        </p:spPr>
+        <p:txBody>
+          <a:bodyPr wrap="square" lIns="0" tIns="0" rIns="0" bIns="0" rtlCol="0" anchor="ctr"/>
+          <a:lstStyle/>
+          <a:p>
+            <a:pPr algn="ctr" indent="0" marL="0">
+              <a:buNone/>
+            </a:pPr>
+            <a:r>
+              <a:rPr lang="en-US" sz="1400" b="1" dirty="0">
+                <a:solidFill>
+                  <a:srgbClr val="FFFFFF"/>
+                </a:solidFill>
+                <a:latin typeface="Arial Black" pitchFamily="34" charset="0"/>
+                <a:ea typeface="Arial Black" pitchFamily="34" charset="-122"/>
+                <a:cs typeface="Arial Black" pitchFamily="34" charset="-120"/>
+              </a:rPr>
+              <a:t>4</a:t>
+            </a:r>
+            <a:endParaRPr lang="en-US" sz="1400" dirty="0"/>
+          </a:p>
+        </p:txBody>
+      </p:sp>
+      <p:sp>
+        <p:nvSpPr>
+          <p:cNvPr id="16" name="Text 14"/>
+          <p:cNvSpPr/>
+          <p:nvPr/>
+        </p:nvSpPr>
+        <p:spPr>
+          <a:xfrm>
+            <a:off x="987552" y="3922776"/>
+            <a:ext cx="7680960" cy="512064"/>
+          </a:xfrm>
+          <a:prstGeom prst="rect">
+            <a:avLst/>
+          </a:prstGeom>
+          <a:noFill/>
+          <a:ln/>
+        </p:spPr>
+        <p:txBody>
+          <a:bodyPr wrap="square" lIns="0" tIns="0" rIns="0" bIns="0" rtlCol="0" anchor="ctr"/>
+          <a:lstStyle/>
+          <a:p>
+            <a:pPr algn="l" indent="0" marL="0">
+              <a:buNone/>
+            </a:pPr>
+            <a:r>
+              <a:rPr lang="en-US" sz="1700" dirty="0">
+                <a:solidFill>
+                  <a:srgbClr val="2A2A2A"/>
+                </a:solidFill>
+                <a:latin typeface="Calibri" pitchFamily="34" charset="0"/>
+                <a:ea typeface="Calibri" pitchFamily="34" charset="-122"/>
+                <a:cs typeface="Calibri" pitchFamily="34" charset="-120"/>
               </a:rPr>
               <a:t>これを何問か繰り返す</a:t>
             </a:r>
-            <a:endParaRPr lang="en-US" sz="2200" dirty="0"/>
+            <a:endParaRPr lang="en-US" sz="1700" dirty="0"/>
           </a:p>
         </p:txBody>
       </p:sp>
@@ -2694,7 +3024,7 @@
         <p:spPr>
           <a:xfrm>
             <a:off x="0" y="0"/>
-            <a:ext cx="164592" cy="5143500"/>
+            <a:ext cx="146304" cy="868680"/>
           </a:xfrm>
           <a:prstGeom prst="rect">
             <a:avLst/>
@@ -2718,8 +3048,8 @@
         </p:nvSpPr>
         <p:spPr>
           <a:xfrm>
-            <a:off x="365760" y="274320"/>
-            <a:ext cx="8412480" cy="822960"/>
+            <a:off x="274320" y="0"/>
+            <a:ext cx="8686800" cy="868680"/>
           </a:xfrm>
           <a:prstGeom prst="rect">
             <a:avLst/>
@@ -2728,24 +3058,24 @@
           <a:ln/>
         </p:spPr>
         <p:txBody>
-          <a:bodyPr wrap="square" rtlCol="0" anchor="ctr"/>
+          <a:bodyPr wrap="square" lIns="0" tIns="0" rIns="0" bIns="0" rtlCol="0" anchor="ctr"/>
           <a:lstStyle/>
           <a:p>
             <a:pPr algn="l" indent="0" marL="0">
               <a:buNone/>
             </a:pPr>
             <a:r>
-              <a:rPr lang="en-US" sz="3400" b="1" dirty="0">
+              <a:rPr lang="en-US" sz="2600" b="1" dirty="0">
                 <a:solidFill>
                   <a:srgbClr val="FFFFFF"/>
                 </a:solidFill>
-                <a:latin typeface="Noto Sans JP" pitchFamily="34" charset="0"/>
-                <a:ea typeface="Noto Sans JP" pitchFamily="34" charset="-122"/>
-                <a:cs typeface="Noto Sans JP" pitchFamily="34" charset="-120"/>
+                <a:latin typeface="Arial Black" pitchFamily="34" charset="0"/>
+                <a:ea typeface="Arial Black" pitchFamily="34" charset="-122"/>
+                <a:cs typeface="Arial Black" pitchFamily="34" charset="-120"/>
               </a:rPr>
               <a:t>勝つコツ</a:t>
             </a:r>
-            <a:endParaRPr lang="en-US" sz="3400" dirty="0"/>
+            <a:endParaRPr lang="en-US" sz="2600" dirty="0"/>
           </a:p>
         </p:txBody>
       </p:sp>
@@ -2757,10 +3087,35 @@
         </p:nvSpPr>
         <p:spPr>
           <a:xfrm>
-            <a:off x="457200" y="1417320"/>
-            <a:ext cx="320040" cy="320040"/>
-          </a:xfrm>
-          <a:prstGeom prst="rect">
+            <a:off x="457200" y="1005840"/>
+            <a:ext cx="8229600" cy="914400"/>
+          </a:xfrm>
+          <a:prstGeom prst="rect">
+            <a:avLst/>
+          </a:prstGeom>
+          <a:solidFill>
+            <a:srgbClr val="1A4060"/>
+          </a:solidFill>
+          <a:ln w="19050">
+            <a:solidFill>
+              <a:srgbClr val="2E7D8C"/>
+            </a:solidFill>
+            <a:prstDash val="solid"/>
+          </a:ln>
+        </p:spPr>
+      </p:sp>
+      <p:sp>
+        <p:nvSpPr>
+          <p:cNvPr id="5" name="Shape 3"/>
+          <p:cNvSpPr/>
+          <p:nvPr/>
+        </p:nvSpPr>
+        <p:spPr>
+          <a:xfrm>
+            <a:off x="621792" y="1261872"/>
+            <a:ext cx="402336" cy="402336"/>
+          </a:xfrm>
+          <a:prstGeom prst="ellipse">
             <a:avLst/>
           </a:prstGeom>
           <a:solidFill>
@@ -2776,14 +3131,14 @@
       </p:sp>
       <p:sp>
         <p:nvSpPr>
-          <p:cNvPr id="5" name="Text 3"/>
-          <p:cNvSpPr/>
-          <p:nvPr/>
-        </p:nvSpPr>
-        <p:spPr>
-          <a:xfrm>
-            <a:off x="1005840" y="1280160"/>
-            <a:ext cx="7680960" cy="658368"/>
+          <p:cNvPr id="6" name="Text 4"/>
+          <p:cNvSpPr/>
+          <p:nvPr/>
+        </p:nvSpPr>
+        <p:spPr>
+          <a:xfrm>
+            <a:off x="621792" y="1261872"/>
+            <a:ext cx="402336" cy="402336"/>
           </a:xfrm>
           <a:prstGeom prst="rect">
             <a:avLst/>
@@ -2792,39 +3147,103 @@
           <a:ln/>
         </p:spPr>
         <p:txBody>
-          <a:bodyPr wrap="square" rtlCol="0" anchor="ctr"/>
+          <a:bodyPr wrap="square" lIns="0" tIns="0" rIns="0" bIns="0" rtlCol="0" anchor="ctr"/>
+          <a:lstStyle/>
+          <a:p>
+            <a:pPr algn="ctr" indent="0" marL="0">
+              <a:buNone/>
+            </a:pPr>
+            <a:r>
+              <a:rPr lang="en-US" sz="1400" b="1" dirty="0">
+                <a:solidFill>
+                  <a:srgbClr val="FFFFFF"/>
+                </a:solidFill>
+                <a:latin typeface="Arial Black" pitchFamily="34" charset="0"/>
+                <a:ea typeface="Arial Black" pitchFamily="34" charset="-122"/>
+                <a:cs typeface="Arial Black" pitchFamily="34" charset="-120"/>
+              </a:rPr>
+              <a:t>1</a:t>
+            </a:r>
+            <a:endParaRPr lang="en-US" sz="1400" dirty="0"/>
+          </a:p>
+        </p:txBody>
+      </p:sp>
+      <p:sp>
+        <p:nvSpPr>
+          <p:cNvPr id="7" name="Text 5"/>
+          <p:cNvSpPr/>
+          <p:nvPr/>
+        </p:nvSpPr>
+        <p:spPr>
+          <a:xfrm>
+            <a:off x="1170432" y="1005840"/>
+            <a:ext cx="7223760" cy="914400"/>
+          </a:xfrm>
+          <a:prstGeom prst="rect">
+            <a:avLst/>
+          </a:prstGeom>
+          <a:noFill/>
+          <a:ln/>
+        </p:spPr>
+        <p:txBody>
+          <a:bodyPr wrap="square" lIns="0" tIns="0" rIns="0" bIns="0" rtlCol="0" anchor="ctr"/>
           <a:lstStyle/>
           <a:p>
             <a:pPr algn="l" indent="0" marL="0">
               <a:buNone/>
             </a:pPr>
             <a:r>
-              <a:rPr lang="en-US" sz="2200" dirty="0">
+              <a:rPr lang="en-US" sz="1900" dirty="0">
                 <a:solidFill>
                   <a:srgbClr val="FFFFFF"/>
                 </a:solidFill>
-                <a:latin typeface="Noto Sans JP" pitchFamily="34" charset="0"/>
-                <a:ea typeface="Noto Sans JP" pitchFamily="34" charset="-122"/>
-                <a:cs typeface="Noto Sans JP" pitchFamily="34" charset="-120"/>
+                <a:latin typeface="Calibri" pitchFamily="34" charset="0"/>
+                <a:ea typeface="Calibri" pitchFamily="34" charset="-122"/>
+                <a:cs typeface="Calibri" pitchFamily="34" charset="-120"/>
               </a:rPr>
               <a:t>みんながどんな数字を答えるか想像しよう</a:t>
             </a:r>
-            <a:endParaRPr lang="en-US" sz="2200" dirty="0"/>
-          </a:p>
-        </p:txBody>
-      </p:sp>
-      <p:sp>
-        <p:nvSpPr>
-          <p:cNvPr id="6" name="Shape 4"/>
-          <p:cNvSpPr/>
-          <p:nvPr/>
-        </p:nvSpPr>
-        <p:spPr>
-          <a:xfrm>
-            <a:off x="457200" y="2514600"/>
-            <a:ext cx="320040" cy="320040"/>
-          </a:xfrm>
-          <a:prstGeom prst="rect">
+            <a:endParaRPr lang="en-US" sz="1900" dirty="0"/>
+          </a:p>
+        </p:txBody>
+      </p:sp>
+      <p:sp>
+        <p:nvSpPr>
+          <p:cNvPr id="8" name="Shape 6"/>
+          <p:cNvSpPr/>
+          <p:nvPr/>
+        </p:nvSpPr>
+        <p:spPr>
+          <a:xfrm>
+            <a:off x="457200" y="2148840"/>
+            <a:ext cx="8229600" cy="914400"/>
+          </a:xfrm>
+          <a:prstGeom prst="rect">
+            <a:avLst/>
+          </a:prstGeom>
+          <a:solidFill>
+            <a:srgbClr val="1A4060"/>
+          </a:solidFill>
+          <a:ln w="19050">
+            <a:solidFill>
+              <a:srgbClr val="2E7D8C"/>
+            </a:solidFill>
+            <a:prstDash val="solid"/>
+          </a:ln>
+        </p:spPr>
+      </p:sp>
+      <p:sp>
+        <p:nvSpPr>
+          <p:cNvPr id="9" name="Shape 7"/>
+          <p:cNvSpPr/>
+          <p:nvPr/>
+        </p:nvSpPr>
+        <p:spPr>
+          <a:xfrm>
+            <a:off x="621792" y="2404872"/>
+            <a:ext cx="402336" cy="402336"/>
+          </a:xfrm>
+          <a:prstGeom prst="ellipse">
             <a:avLst/>
           </a:prstGeom>
           <a:solidFill>
@@ -2840,14 +3259,14 @@
       </p:sp>
       <p:sp>
         <p:nvSpPr>
-          <p:cNvPr id="7" name="Text 5"/>
-          <p:cNvSpPr/>
-          <p:nvPr/>
-        </p:nvSpPr>
-        <p:spPr>
-          <a:xfrm>
-            <a:off x="1005840" y="2377440"/>
-            <a:ext cx="7680960" cy="658368"/>
+          <p:cNvPr id="10" name="Text 8"/>
+          <p:cNvSpPr/>
+          <p:nvPr/>
+        </p:nvSpPr>
+        <p:spPr>
+          <a:xfrm>
+            <a:off x="621792" y="2404872"/>
+            <a:ext cx="402336" cy="402336"/>
           </a:xfrm>
           <a:prstGeom prst="rect">
             <a:avLst/>
@@ -2856,39 +3275,103 @@
           <a:ln/>
         </p:spPr>
         <p:txBody>
-          <a:bodyPr wrap="square" rtlCol="0" anchor="ctr"/>
+          <a:bodyPr wrap="square" lIns="0" tIns="0" rIns="0" bIns="0" rtlCol="0" anchor="ctr"/>
+          <a:lstStyle/>
+          <a:p>
+            <a:pPr algn="ctr" indent="0" marL="0">
+              <a:buNone/>
+            </a:pPr>
+            <a:r>
+              <a:rPr lang="en-US" sz="1400" b="1" dirty="0">
+                <a:solidFill>
+                  <a:srgbClr val="FFFFFF"/>
+                </a:solidFill>
+                <a:latin typeface="Arial Black" pitchFamily="34" charset="0"/>
+                <a:ea typeface="Arial Black" pitchFamily="34" charset="-122"/>
+                <a:cs typeface="Arial Black" pitchFamily="34" charset="-120"/>
+              </a:rPr>
+              <a:t>2</a:t>
+            </a:r>
+            <a:endParaRPr lang="en-US" sz="1400" dirty="0"/>
+          </a:p>
+        </p:txBody>
+      </p:sp>
+      <p:sp>
+        <p:nvSpPr>
+          <p:cNvPr id="11" name="Text 9"/>
+          <p:cNvSpPr/>
+          <p:nvPr/>
+        </p:nvSpPr>
+        <p:spPr>
+          <a:xfrm>
+            <a:off x="1170432" y="2148840"/>
+            <a:ext cx="7223760" cy="914400"/>
+          </a:xfrm>
+          <a:prstGeom prst="rect">
+            <a:avLst/>
+          </a:prstGeom>
+          <a:noFill/>
+          <a:ln/>
+        </p:spPr>
+        <p:txBody>
+          <a:bodyPr wrap="square" lIns="0" tIns="0" rIns="0" bIns="0" rtlCol="0" anchor="ctr"/>
           <a:lstStyle/>
           <a:p>
             <a:pPr algn="l" indent="0" marL="0">
               <a:buNone/>
             </a:pPr>
             <a:r>
-              <a:rPr lang="en-US" sz="2200" dirty="0">
+              <a:rPr lang="en-US" sz="1900" dirty="0">
                 <a:solidFill>
                   <a:srgbClr val="FFFFFF"/>
                 </a:solidFill>
-                <a:latin typeface="Noto Sans JP" pitchFamily="34" charset="0"/>
-                <a:ea typeface="Noto Sans JP" pitchFamily="34" charset="-122"/>
-                <a:cs typeface="Noto Sans JP" pitchFamily="34" charset="-120"/>
+                <a:latin typeface="Calibri" pitchFamily="34" charset="0"/>
+                <a:ea typeface="Calibri" pitchFamily="34" charset="-122"/>
+                <a:cs typeface="Calibri" pitchFamily="34" charset="-120"/>
               </a:rPr>
               <a:t>極端な数字は避けるのが安全</a:t>
             </a:r>
-            <a:endParaRPr lang="en-US" sz="2200" dirty="0"/>
-          </a:p>
-        </p:txBody>
-      </p:sp>
-      <p:sp>
-        <p:nvSpPr>
-          <p:cNvPr id="8" name="Shape 6"/>
-          <p:cNvSpPr/>
-          <p:nvPr/>
-        </p:nvSpPr>
-        <p:spPr>
-          <a:xfrm>
-            <a:off x="457200" y="3611880"/>
-            <a:ext cx="320040" cy="320040"/>
-          </a:xfrm>
-          <a:prstGeom prst="rect">
+            <a:endParaRPr lang="en-US" sz="1900" dirty="0"/>
+          </a:p>
+        </p:txBody>
+      </p:sp>
+      <p:sp>
+        <p:nvSpPr>
+          <p:cNvPr id="12" name="Shape 10"/>
+          <p:cNvSpPr/>
+          <p:nvPr/>
+        </p:nvSpPr>
+        <p:spPr>
+          <a:xfrm>
+            <a:off x="457200" y="3291840"/>
+            <a:ext cx="8229600" cy="914400"/>
+          </a:xfrm>
+          <a:prstGeom prst="rect">
+            <a:avLst/>
+          </a:prstGeom>
+          <a:solidFill>
+            <a:srgbClr val="1A4060"/>
+          </a:solidFill>
+          <a:ln w="19050">
+            <a:solidFill>
+              <a:srgbClr val="2E7D8C"/>
+            </a:solidFill>
+            <a:prstDash val="solid"/>
+          </a:ln>
+        </p:spPr>
+      </p:sp>
+      <p:sp>
+        <p:nvSpPr>
+          <p:cNvPr id="13" name="Shape 11"/>
+          <p:cNvSpPr/>
+          <p:nvPr/>
+        </p:nvSpPr>
+        <p:spPr>
+          <a:xfrm>
+            <a:off x="621792" y="3547872"/>
+            <a:ext cx="402336" cy="402336"/>
+          </a:xfrm>
+          <a:prstGeom prst="ellipse">
             <a:avLst/>
           </a:prstGeom>
           <a:solidFill>
@@ -2904,14 +3387,14 @@
       </p:sp>
       <p:sp>
         <p:nvSpPr>
-          <p:cNvPr id="9" name="Text 7"/>
-          <p:cNvSpPr/>
-          <p:nvPr/>
-        </p:nvSpPr>
-        <p:spPr>
-          <a:xfrm>
-            <a:off x="1005840" y="3474720"/>
-            <a:ext cx="7680960" cy="658368"/>
+          <p:cNvPr id="14" name="Text 12"/>
+          <p:cNvSpPr/>
+          <p:nvPr/>
+        </p:nvSpPr>
+        <p:spPr>
+          <a:xfrm>
+            <a:off x="621792" y="3547872"/>
+            <a:ext cx="402336" cy="402336"/>
           </a:xfrm>
           <a:prstGeom prst="rect">
             <a:avLst/>
@@ -2920,24 +3403,63 @@
           <a:ln/>
         </p:spPr>
         <p:txBody>
-          <a:bodyPr wrap="square" rtlCol="0" anchor="ctr"/>
+          <a:bodyPr wrap="square" lIns="0" tIns="0" rIns="0" bIns="0" rtlCol="0" anchor="ctr"/>
+          <a:lstStyle/>
+          <a:p>
+            <a:pPr algn="ctr" indent="0" marL="0">
+              <a:buNone/>
+            </a:pPr>
+            <a:r>
+              <a:rPr lang="en-US" sz="1400" b="1" dirty="0">
+                <a:solidFill>
+                  <a:srgbClr val="FFFFFF"/>
+                </a:solidFill>
+                <a:latin typeface="Arial Black" pitchFamily="34" charset="0"/>
+                <a:ea typeface="Arial Black" pitchFamily="34" charset="-122"/>
+                <a:cs typeface="Arial Black" pitchFamily="34" charset="-120"/>
+              </a:rPr>
+              <a:t>3</a:t>
+            </a:r>
+            <a:endParaRPr lang="en-US" sz="1400" dirty="0"/>
+          </a:p>
+        </p:txBody>
+      </p:sp>
+      <p:sp>
+        <p:nvSpPr>
+          <p:cNvPr id="15" name="Text 13"/>
+          <p:cNvSpPr/>
+          <p:nvPr/>
+        </p:nvSpPr>
+        <p:spPr>
+          <a:xfrm>
+            <a:off x="1170432" y="3291840"/>
+            <a:ext cx="7223760" cy="914400"/>
+          </a:xfrm>
+          <a:prstGeom prst="rect">
+            <a:avLst/>
+          </a:prstGeom>
+          <a:noFill/>
+          <a:ln/>
+        </p:spPr>
+        <p:txBody>
+          <a:bodyPr wrap="square" lIns="0" tIns="0" rIns="0" bIns="0" rtlCol="0" anchor="ctr"/>
           <a:lstStyle/>
           <a:p>
             <a:pPr algn="l" indent="0" marL="0">
               <a:buNone/>
             </a:pPr>
             <a:r>
-              <a:rPr lang="en-US" sz="2200" dirty="0">
+              <a:rPr lang="en-US" sz="1900" dirty="0">
                 <a:solidFill>
                   <a:srgbClr val="FFFFFF"/>
                 </a:solidFill>
-                <a:latin typeface="Noto Sans JP" pitchFamily="34" charset="0"/>
-                <a:ea typeface="Noto Sans JP" pitchFamily="34" charset="-122"/>
-                <a:cs typeface="Noto Sans JP" pitchFamily="34" charset="-120"/>
+                <a:latin typeface="Calibri" pitchFamily="34" charset="0"/>
+                <a:ea typeface="Calibri" pitchFamily="34" charset="-122"/>
+                <a:cs typeface="Calibri" pitchFamily="34" charset="-120"/>
               </a:rPr>
               <a:t>でも、みんなが同じことを考えてたら…？</a:t>
             </a:r>
-            <a:endParaRPr lang="en-US" sz="2200" dirty="0"/>
+            <a:endParaRPr lang="en-US" sz="1900" dirty="0"/>
           </a:p>
         </p:txBody>
       </p:sp>
@@ -2982,7 +3504,7 @@
         <p:spPr>
           <a:xfrm>
             <a:off x="0" y="0"/>
-            <a:ext cx="9144000" cy="914400"/>
+            <a:ext cx="9144000" cy="868680"/>
           </a:xfrm>
           <a:prstGeom prst="rect">
             <a:avLst/>
@@ -3000,61 +3522,22 @@
       </p:sp>
       <p:sp>
         <p:nvSpPr>
-          <p:cNvPr id="3" name="Text 1"/>
-          <p:cNvSpPr/>
-          <p:nvPr/>
-        </p:nvSpPr>
-        <p:spPr>
-          <a:xfrm>
-            <a:off x="365760" y="0"/>
-            <a:ext cx="8412480" cy="914400"/>
-          </a:xfrm>
-          <a:prstGeom prst="rect">
-            <a:avLst/>
-          </a:prstGeom>
-          <a:noFill/>
-          <a:ln/>
-        </p:spPr>
-        <p:txBody>
-          <a:bodyPr wrap="square" lIns="0" tIns="0" rIns="0" bIns="0" rtlCol="0" anchor="ctr"/>
-          <a:lstStyle/>
-          <a:p>
-            <a:pPr algn="l" indent="0" marL="0">
-              <a:buNone/>
-            </a:pPr>
-            <a:r>
-              <a:rPr lang="en-US" sz="2800" b="1" dirty="0">
-                <a:solidFill>
-                  <a:srgbClr val="FFFFFF"/>
-                </a:solidFill>
-                <a:latin typeface="Noto Sans JP" pitchFamily="34" charset="0"/>
-                <a:ea typeface="Noto Sans JP" pitchFamily="34" charset="-122"/>
-                <a:cs typeface="Noto Sans JP" pitchFamily="34" charset="-120"/>
-              </a:rPr>
-              <a:t>チャットにコピーして使おう</a:t>
-            </a:r>
-            <a:endParaRPr lang="en-US" sz="2800" dirty="0"/>
-          </a:p>
-        </p:txBody>
-      </p:sp>
-      <p:sp>
-        <p:nvSpPr>
-          <p:cNvPr id="4" name="Shape 2"/>
-          <p:cNvSpPr/>
-          <p:nvPr/>
-        </p:nvSpPr>
-        <p:spPr>
-          <a:xfrm>
-            <a:off x="365760" y="1051560"/>
-            <a:ext cx="8412480" cy="3840480"/>
-          </a:xfrm>
-          <a:prstGeom prst="rect">
-            <a:avLst/>
-          </a:prstGeom>
-          <a:solidFill>
-            <a:srgbClr val="FFFFFF"/>
-          </a:solidFill>
-          <a:ln w="31750">
+          <p:cNvPr id="3" name="Shape 1"/>
+          <p:cNvSpPr/>
+          <p:nvPr/>
+        </p:nvSpPr>
+        <p:spPr>
+          <a:xfrm>
+            <a:off x="0" y="0"/>
+            <a:ext cx="146304" cy="868680"/>
+          </a:xfrm>
+          <a:prstGeom prst="rect">
+            <a:avLst/>
+          </a:prstGeom>
+          <a:solidFill>
+            <a:srgbClr val="2E7D8C"/>
+          </a:solidFill>
+          <a:ln w="12700">
             <a:solidFill>
               <a:srgbClr val="2E7D8C"/>
             </a:solidFill>
@@ -3064,14 +3547,14 @@
       </p:sp>
       <p:sp>
         <p:nvSpPr>
-          <p:cNvPr id="5" name="Text 3"/>
-          <p:cNvSpPr/>
-          <p:nvPr/>
-        </p:nvSpPr>
-        <p:spPr>
-          <a:xfrm>
-            <a:off x="548640" y="1143000"/>
-            <a:ext cx="8046720" cy="3657600"/>
+          <p:cNvPr id="4" name="Text 2"/>
+          <p:cNvSpPr/>
+          <p:nvPr/>
+        </p:nvSpPr>
+        <p:spPr>
+          <a:xfrm>
+            <a:off x="274320" y="0"/>
+            <a:ext cx="8686800" cy="868680"/>
           </a:xfrm>
           <a:prstGeom prst="rect">
             <a:avLst/>
@@ -3080,225 +3563,275 @@
           <a:ln/>
         </p:spPr>
         <p:txBody>
-          <a:bodyPr wrap="square" rtlCol="0" anchor="t"/>
+          <a:bodyPr wrap="square" lIns="0" tIns="0" rIns="0" bIns="0" rtlCol="0" anchor="ctr"/>
           <a:lstStyle/>
           <a:p>
             <a:pPr algn="l" indent="0" marL="0">
-              <a:lnSpc>
-                <a:spcPct val="130000"/>
-              </a:lnSpc>
-              <a:buNone/>
-            </a:pPr>
-            <a:r>
-              <a:rPr lang="en-US" sz="1600" b="1" dirty="0">
-                <a:solidFill>
-                  <a:srgbClr val="1A1A1A"/>
-                </a:solidFill>
-                <a:latin typeface="Courier New" pitchFamily="34" charset="0"/>
-                <a:ea typeface="Courier New" pitchFamily="34" charset="-122"/>
-                <a:cs typeface="Courier New" pitchFamily="34" charset="-120"/>
+              <a:buNone/>
+            </a:pPr>
+            <a:r>
+              <a:rPr lang="en-US" sz="2600" b="1" dirty="0">
+                <a:solidFill>
+                  <a:srgbClr val="FFFFFF"/>
+                </a:solidFill>
+                <a:latin typeface="Arial Black" pitchFamily="34" charset="0"/>
+                <a:ea typeface="Arial Black" pitchFamily="34" charset="-122"/>
+                <a:cs typeface="Arial Black" pitchFamily="34" charset="-120"/>
+              </a:rPr>
+              <a:t>チャットにコピーして使おう</a:t>
+            </a:r>
+            <a:endParaRPr lang="en-US" sz="2600" dirty="0"/>
+          </a:p>
+        </p:txBody>
+      </p:sp>
+      <p:sp>
+        <p:nvSpPr>
+          <p:cNvPr id="5" name="Shape 3"/>
+          <p:cNvSpPr/>
+          <p:nvPr/>
+        </p:nvSpPr>
+        <p:spPr>
+          <a:xfrm>
+            <a:off x="457200" y="960120"/>
+            <a:ext cx="8229600" cy="3931920"/>
+          </a:xfrm>
+          <a:prstGeom prst="rect">
+            <a:avLst/>
+          </a:prstGeom>
+          <a:solidFill>
+            <a:srgbClr val="1A2835"/>
+          </a:solidFill>
+          <a:ln w="25400">
+            <a:solidFill>
+              <a:srgbClr val="2E7D8C"/>
+            </a:solidFill>
+            <a:prstDash val="solid"/>
+          </a:ln>
+        </p:spPr>
+      </p:sp>
+      <p:sp>
+        <p:nvSpPr>
+          <p:cNvPr id="6" name="Text 4"/>
+          <p:cNvSpPr/>
+          <p:nvPr/>
+        </p:nvSpPr>
+        <p:spPr>
+          <a:xfrm>
+            <a:off x="640080" y="1051560"/>
+            <a:ext cx="7863840" cy="3749040"/>
+          </a:xfrm>
+          <a:prstGeom prst="rect">
+            <a:avLst/>
+          </a:prstGeom>
+          <a:noFill/>
+          <a:ln/>
+        </p:spPr>
+        <p:txBody>
+          <a:bodyPr wrap="square" lIns="1905" tIns="1905" rIns="1905" bIns="1905" rtlCol="0" anchor="t"/>
+          <a:lstStyle/>
+          <a:p>
+            <a:pPr algn="l" indent="0" marL="0">
+              <a:buNone/>
+            </a:pPr>
+            <a:r>
+              <a:rPr lang="en-US" sz="1500" b="1" dirty="0">
+                <a:solidFill>
+                  <a:srgbClr val="5EC8D8"/>
+                </a:solidFill>
+                <a:latin typeface="Consolas" pitchFamily="34" charset="0"/>
+                <a:ea typeface="Consolas" pitchFamily="34" charset="-122"/>
+                <a:cs typeface="Consolas" pitchFamily="34" charset="-120"/>
               </a:rPr>
               <a:t>【いいセンいきまSHOW! ルール】</a:t>
             </a:r>
-            <a:endParaRPr lang="en-US" sz="1600" dirty="0"/>
+            <a:endParaRPr lang="en-US" sz="1500" dirty="0"/>
           </a:p>
           <a:p>
             <a:pPr algn="l" indent="0" marL="0">
-              <a:lnSpc>
-                <a:spcPct val="130000"/>
-              </a:lnSpc>
-              <a:buNone/>
-            </a:pPr>
-            <a:r>
-              <a:rPr lang="en-US" sz="1600" dirty="0">
-                <a:solidFill>
-                  <a:srgbClr val="1A1A1A"/>
-                </a:solidFill>
-                <a:latin typeface="Courier New" pitchFamily="34" charset="0"/>
-                <a:ea typeface="Courier New" pitchFamily="34" charset="-122"/>
-                <a:cs typeface="Courier New" pitchFamily="34" charset="-120"/>
+              <a:buNone/>
+            </a:pPr>
+            <a:r>
+              <a:rPr lang="en-US" sz="1400" dirty="0">
+                <a:solidFill>
+                  <a:srgbClr val="DDDDDD"/>
+                </a:solidFill>
+                <a:latin typeface="Consolas" pitchFamily="34" charset="0"/>
+                <a:ea typeface="Consolas" pitchFamily="34" charset="-122"/>
+                <a:cs typeface="Consolas" pitchFamily="34" charset="-120"/>
               </a:rPr>
               <a:t>数字で「いいセン」をねらうゲームだよ！</a:t>
             </a:r>
-            <a:endParaRPr lang="en-US" sz="1600" dirty="0"/>
+            <a:endParaRPr lang="en-US" sz="1500" dirty="0"/>
           </a:p>
           <a:p>
             <a:pPr algn="l" indent="0" marL="0">
-              <a:lnSpc>
-                <a:spcPct val="130000"/>
-              </a:lnSpc>
-              <a:buNone/>
-            </a:pPr>
-            <a:endParaRPr lang="en-US" sz="1600" dirty="0"/>
+              <a:buNone/>
+            </a:pPr>
+            <a:r>
+              <a:rPr lang="en-US" sz="800" dirty="0">
+                <a:solidFill>
+                  <a:srgbClr val="000000"/>
+                </a:solidFill>
+                <a:latin typeface="Consolas" pitchFamily="34" charset="0"/>
+                <a:ea typeface="Consolas" pitchFamily="34" charset="-122"/>
+                <a:cs typeface="Consolas" pitchFamily="34" charset="-120"/>
+              </a:rPr>
+              <a:t> </a:t>
+            </a:r>
+            <a:endParaRPr lang="en-US" sz="1500" dirty="0"/>
           </a:p>
           <a:p>
             <a:pPr algn="l" indent="0" marL="0">
-              <a:lnSpc>
-                <a:spcPct val="130000"/>
-              </a:lnSpc>
-              <a:buNone/>
-            </a:pPr>
-            <a:r>
-              <a:rPr lang="en-US" sz="1600" b="1" dirty="0">
-                <a:solidFill>
-                  <a:srgbClr val="1A1A1A"/>
-                </a:solidFill>
-                <a:latin typeface="Courier New" pitchFamily="34" charset="0"/>
-                <a:ea typeface="Courier New" pitchFamily="34" charset="-122"/>
-                <a:cs typeface="Courier New" pitchFamily="34" charset="-120"/>
-              </a:rPr>
-              <a:t>得点ルール</a:t>
-            </a:r>
-            <a:endParaRPr lang="en-US" sz="1600" dirty="0"/>
+              <a:buNone/>
+            </a:pPr>
+            <a:r>
+              <a:rPr lang="en-US" sz="1500" b="1" dirty="0">
+                <a:solidFill>
+                  <a:srgbClr val="5EC8D8"/>
+                </a:solidFill>
+                <a:latin typeface="Consolas" pitchFamily="34" charset="0"/>
+                <a:ea typeface="Consolas" pitchFamily="34" charset="-122"/>
+                <a:cs typeface="Consolas" pitchFamily="34" charset="-120"/>
+              </a:rPr>
+              <a:t>■ 得点ルール</a:t>
+            </a:r>
+            <a:endParaRPr lang="en-US" sz="1500" dirty="0"/>
           </a:p>
           <a:p>
             <a:pPr algn="l" indent="0" marL="0">
-              <a:lnSpc>
-                <a:spcPct val="130000"/>
-              </a:lnSpc>
-              <a:buNone/>
-            </a:pPr>
-            <a:r>
-              <a:rPr lang="en-US" sz="1600" dirty="0">
-                <a:solidFill>
-                  <a:srgbClr val="1A1A1A"/>
-                </a:solidFill>
-                <a:latin typeface="Courier New" pitchFamily="34" charset="0"/>
-                <a:ea typeface="Courier New" pitchFamily="34" charset="-122"/>
-                <a:cs typeface="Courier New" pitchFamily="34" charset="-120"/>
+              <a:buNone/>
+            </a:pPr>
+            <a:r>
+              <a:rPr lang="en-US" sz="1400" dirty="0">
+                <a:solidFill>
+                  <a:srgbClr val="DDDDDD"/>
+                </a:solidFill>
+                <a:latin typeface="Consolas" pitchFamily="34" charset="0"/>
+                <a:ea typeface="Consolas" pitchFamily="34" charset="-122"/>
+                <a:cs typeface="Consolas" pitchFamily="34" charset="-120"/>
               </a:rPr>
               <a:t>・ちょうど真ん中の数字 → ＋50点</a:t>
             </a:r>
-            <a:endParaRPr lang="en-US" sz="1600" dirty="0"/>
+            <a:endParaRPr lang="en-US" sz="1500" dirty="0"/>
           </a:p>
           <a:p>
             <a:pPr algn="l" indent="0" marL="0">
-              <a:lnSpc>
-                <a:spcPct val="130000"/>
-              </a:lnSpc>
-              <a:buNone/>
-            </a:pPr>
-            <a:r>
-              <a:rPr lang="en-US" sz="1600" dirty="0">
-                <a:solidFill>
-                  <a:srgbClr val="1A1A1A"/>
-                </a:solidFill>
-                <a:latin typeface="Courier New" pitchFamily="34" charset="0"/>
-                <a:ea typeface="Courier New" pitchFamily="34" charset="-122"/>
-                <a:cs typeface="Courier New" pitchFamily="34" charset="-120"/>
+              <a:buNone/>
+            </a:pPr>
+            <a:r>
+              <a:rPr lang="en-US" sz="1400" dirty="0">
+                <a:solidFill>
+                  <a:srgbClr val="DDDDDD"/>
+                </a:solidFill>
+                <a:latin typeface="Consolas" pitchFamily="34" charset="0"/>
+                <a:ea typeface="Consolas" pitchFamily="34" charset="-122"/>
+                <a:cs typeface="Consolas" pitchFamily="34" charset="-120"/>
               </a:rPr>
               <a:t>・いちばん大きい or 小さい数字 → －10点</a:t>
             </a:r>
-            <a:endParaRPr lang="en-US" sz="1600" dirty="0"/>
+            <a:endParaRPr lang="en-US" sz="1500" dirty="0"/>
           </a:p>
           <a:p>
             <a:pPr algn="l" indent="0" marL="0">
-              <a:lnSpc>
-                <a:spcPct val="130000"/>
-              </a:lnSpc>
-              <a:buNone/>
-            </a:pPr>
-            <a:r>
-              <a:rPr lang="en-US" sz="1600" dirty="0">
-                <a:solidFill>
-                  <a:srgbClr val="1A1A1A"/>
-                </a:solidFill>
-                <a:latin typeface="Courier New" pitchFamily="34" charset="0"/>
-                <a:ea typeface="Courier New" pitchFamily="34" charset="-122"/>
-                <a:cs typeface="Courier New" pitchFamily="34" charset="-120"/>
+              <a:buNone/>
+            </a:pPr>
+            <a:r>
+              <a:rPr lang="en-US" sz="1400" dirty="0">
+                <a:solidFill>
+                  <a:srgbClr val="DDDDDD"/>
+                </a:solidFill>
+                <a:latin typeface="Consolas" pitchFamily="34" charset="0"/>
+                <a:ea typeface="Consolas" pitchFamily="34" charset="-122"/>
+                <a:cs typeface="Consolas" pitchFamily="34" charset="-120"/>
               </a:rPr>
               <a:t>・それ以外 → 0点</a:t>
             </a:r>
-            <a:endParaRPr lang="en-US" sz="1600" dirty="0"/>
+            <a:endParaRPr lang="en-US" sz="1500" dirty="0"/>
           </a:p>
           <a:p>
             <a:pPr algn="l" indent="0" marL="0">
-              <a:lnSpc>
-                <a:spcPct val="130000"/>
-              </a:lnSpc>
-              <a:buNone/>
-            </a:pPr>
-            <a:endParaRPr lang="en-US" sz="1600" dirty="0"/>
+              <a:buNone/>
+            </a:pPr>
+            <a:r>
+              <a:rPr lang="en-US" sz="800" dirty="0">
+                <a:solidFill>
+                  <a:srgbClr val="000000"/>
+                </a:solidFill>
+                <a:latin typeface="Consolas" pitchFamily="34" charset="0"/>
+                <a:ea typeface="Consolas" pitchFamily="34" charset="-122"/>
+                <a:cs typeface="Consolas" pitchFamily="34" charset="-120"/>
+              </a:rPr>
+              <a:t> </a:t>
+            </a:r>
+            <a:endParaRPr lang="en-US" sz="1500" dirty="0"/>
           </a:p>
           <a:p>
             <a:pPr algn="l" indent="0" marL="0">
-              <a:lnSpc>
-                <a:spcPct val="130000"/>
-              </a:lnSpc>
-              <a:buNone/>
-            </a:pPr>
-            <a:r>
-              <a:rPr lang="en-US" sz="1600" b="1" dirty="0">
-                <a:solidFill>
-                  <a:srgbClr val="1A1A1A"/>
-                </a:solidFill>
-                <a:latin typeface="Courier New" pitchFamily="34" charset="0"/>
-                <a:ea typeface="Courier New" pitchFamily="34" charset="-122"/>
-                <a:cs typeface="Courier New" pitchFamily="34" charset="-120"/>
-              </a:rPr>
-              <a:t>遊び方</a:t>
-            </a:r>
-            <a:endParaRPr lang="en-US" sz="1600" dirty="0"/>
+              <a:buNone/>
+            </a:pPr>
+            <a:r>
+              <a:rPr lang="en-US" sz="1500" b="1" dirty="0">
+                <a:solidFill>
+                  <a:srgbClr val="5EC8D8"/>
+                </a:solidFill>
+                <a:latin typeface="Consolas" pitchFamily="34" charset="0"/>
+                <a:ea typeface="Consolas" pitchFamily="34" charset="-122"/>
+                <a:cs typeface="Consolas" pitchFamily="34" charset="-120"/>
+              </a:rPr>
+              <a:t>■ 遊び方</a:t>
+            </a:r>
+            <a:endParaRPr lang="en-US" sz="1500" dirty="0"/>
           </a:p>
           <a:p>
             <a:pPr algn="l" indent="0" marL="0">
-              <a:lnSpc>
-                <a:spcPct val="130000"/>
-              </a:lnSpc>
-              <a:buNone/>
-            </a:pPr>
-            <a:r>
-              <a:rPr lang="en-US" sz="1600" dirty="0">
-                <a:solidFill>
-                  <a:srgbClr val="1A1A1A"/>
-                </a:solidFill>
-                <a:latin typeface="Courier New" pitchFamily="34" charset="0"/>
-                <a:ea typeface="Courier New" pitchFamily="34" charset="-122"/>
-                <a:cs typeface="Courier New" pitchFamily="34" charset="-120"/>
+              <a:buNone/>
+            </a:pPr>
+            <a:r>
+              <a:rPr lang="en-US" sz="1400" dirty="0">
+                <a:solidFill>
+                  <a:srgbClr val="DDDDDD"/>
+                </a:solidFill>
+                <a:latin typeface="Consolas" pitchFamily="34" charset="0"/>
+                <a:ea typeface="Consolas" pitchFamily="34" charset="-122"/>
+                <a:cs typeface="Consolas" pitchFamily="34" charset="-120"/>
               </a:rPr>
               <a:t>1. ルームコードを入力して参加</a:t>
             </a:r>
-            <a:endParaRPr lang="en-US" sz="1600" dirty="0"/>
+            <a:endParaRPr lang="en-US" sz="1500" dirty="0"/>
           </a:p>
           <a:p>
             <a:pPr algn="l" indent="0" marL="0">
-              <a:lnSpc>
-                <a:spcPct val="130000"/>
-              </a:lnSpc>
-              <a:buNone/>
-            </a:pPr>
-            <a:r>
-              <a:rPr lang="en-US" sz="1600" dirty="0">
-                <a:solidFill>
-                  <a:srgbClr val="1A1A1A"/>
-                </a:solidFill>
-                <a:latin typeface="Courier New" pitchFamily="34" charset="0"/>
-                <a:ea typeface="Courier New" pitchFamily="34" charset="-122"/>
-                <a:cs typeface="Courier New" pitchFamily="34" charset="-120"/>
+              <a:buNone/>
+            </a:pPr>
+            <a:r>
+              <a:rPr lang="en-US" sz="1400" dirty="0">
+                <a:solidFill>
+                  <a:srgbClr val="DDDDDD"/>
+                </a:solidFill>
+                <a:latin typeface="Consolas" pitchFamily="34" charset="0"/>
+                <a:ea typeface="Consolas" pitchFamily="34" charset="-122"/>
+                <a:cs typeface="Consolas" pitchFamily="34" charset="-120"/>
               </a:rPr>
               <a:t>2. 問題が出たら数字で答えよう</a:t>
             </a:r>
-            <a:endParaRPr lang="en-US" sz="1600" dirty="0"/>
+            <a:endParaRPr lang="en-US" sz="1500" dirty="0"/>
           </a:p>
           <a:p>
             <a:pPr algn="l" indent="0" marL="0">
-              <a:lnSpc>
-                <a:spcPct val="130000"/>
-              </a:lnSpc>
-              <a:buNone/>
-            </a:pPr>
-            <a:r>
-              <a:rPr lang="en-US" sz="1600" dirty="0">
-                <a:solidFill>
-                  <a:srgbClr val="1A1A1A"/>
-                </a:solidFill>
-                <a:latin typeface="Courier New" pitchFamily="34" charset="0"/>
-                <a:ea typeface="Courier New" pitchFamily="34" charset="-122"/>
-                <a:cs typeface="Courier New" pitchFamily="34" charset="-120"/>
+              <a:buNone/>
+            </a:pPr>
+            <a:r>
+              <a:rPr lang="en-US" sz="1400" dirty="0">
+                <a:solidFill>
+                  <a:srgbClr val="DDDDDD"/>
+                </a:solidFill>
+                <a:latin typeface="Consolas" pitchFamily="34" charset="0"/>
+                <a:ea typeface="Consolas" pitchFamily="34" charset="-122"/>
+                <a:cs typeface="Consolas" pitchFamily="34" charset="-120"/>
               </a:rPr>
               <a:t>3. 全員が答えたら結果発表！</a:t>
             </a:r>
-            <a:endParaRPr lang="en-US" sz="1600" dirty="0"/>
+            <a:endParaRPr lang="en-US" sz="1500" dirty="0"/>
           </a:p>
         </p:txBody>
       </p:sp>

</xml_diff>